<commit_message>
Entrega as sete armadilhas prometidas na capa do deck
A capa anunciava "7 armadilhas" mas o deck detalhava cinco, espalhadas
entre os slides, e nunca as apresentava como conjunto - o truncamento das
descricoes e a diferenca entre competencia e mes do acidente nao
apareciam em lugar nenhum.

Novo slide 5 lista as sete na mesma ordem de gravidade de
docs/qualidade-dos-dados.md, com as duas mais graves em ambar, que sao as
detalhadas nos dois slides seguintes. O fecho do slide diz o que elas tem
em comum: nenhuma quebra o codigo, todas dao resultado errado em
silencio.

Co-Authored-By: Claude Opus 5 <noreply@anthropic.com>
Claude-Session: https://claude.ai/code/session_01LocJefDeKRSQ3MygFsBAMi
</commit_message>
<xml_diff>
--- a/reports/apresentacao/apresentacao-cat.pptx
+++ b/reports/apresentacao/apresentacao-cat.pptx
@@ -15,9 +15,10 @@
     <p:sldId id="263" r:id="rId9"/>
     <p:sldId id="264" r:id="rId10"/>
     <p:sldId id="265" r:id="rId11"/>
+    <p:sldId id="266" r:id="rId12"/>
   </p:sldIdLst>
   <p:notesMasterIdLst>
-    <p:notesMasterId r:id="rId12"/>
+    <p:notesMasterId r:id="rId13"/>
   </p:notesMasterIdLst>
   <p:sldSz cx="9144000" cy="5143500"/>
   <p:notesSz cx="5143500" cy="9144000"/>
@@ -511,7 +512,7 @@
           <a:p>
             <a:r>
               <a:rPr lang="en-US" dirty="0"/>
-              <a:t>Trabalhamos com os microdados de CAT: toda comunicação de acidente de trabalho registrada na Previdência. Em sete minutos vamos percorrer o workflow que construímos, as decisões que tomamos e o que os dados revelaram.</a:t>
+              <a:t>Trabalhamos com os microdados de CAT: toda comunicação de acidente de trabalho registrada na Previdência. Em sete minutos vamos percorrer o workflow que construímos, as sete armadilhas que encontramos nos dados e o que eles revelaram.</a:t>
             </a:r>
             <a:endParaRPr lang="en-US" dirty="0"/>
           </a:p>
@@ -599,7 +600,7 @@
           <a:p>
             <a:r>
               <a:rPr lang="en-US" dirty="0"/>
-              <a:t>A EDA fez quatro coisas pelo artigo. Delimitou o escopo: a geografia só pode ser do empregador. Deu a hipótese do trânsito. Expôs a limitação central — sem denominador de exposição, estamos medindo composição, não risco. E definiu o próximo passo: cruzar tipo com setor e buscar vínculos da RAIS.</a:t>
+              <a:t>O achado principal. O trajeto é minoria dos acidentes, mas o mais letal — 2,7 vezes o típico. E o setor mais letal é o transporte rodoviário de carga, com quatro vezes a média geral. Duas análises independentes apontando para o trânsito. É a hipótese que vamos aprofundar.</a:t>
             </a:r>
             <a:endParaRPr lang="en-US" dirty="0"/>
           </a:p>
@@ -623,6 +624,94 @@
             <a:fld id="{F7021451-1387-4CA6-816F-3879F97B5CBC}" type="slidenum">
               <a:rPr lang="en-US"/>
               <a:t>10</a:t>
+            </a:fld>
+            <a:endParaRPr lang="en-US"/>
+          </a:p>
+        </p:txBody>
+      </p:sp>
+    </p:spTree>
+    <p:extLst>
+      <p:ext uri="{BB962C8B-B14F-4D97-AF65-F5344CB8AC3E}">
+        <p14:creationId xmlns:p14="http://schemas.microsoft.com/office/powerpoint/2010/main" val="1024086991"/>
+      </p:ext>
+    </p:extLst>
+  </p:cSld>
+  <p:clrMapOvr>
+    <a:masterClrMapping/>
+  </p:clrMapOvr>
+</p:notes>
+</file>
+
+<file path=ppt/notesSlides/notesSlide11.xml><?xml version="1.0" encoding="utf-8"?>
+<p:notes xmlns:a="http://schemas.openxmlformats.org/drawingml/2006/main" xmlns:r="http://schemas.openxmlformats.org/officeDocument/2006/relationships" xmlns:p="http://schemas.openxmlformats.org/presentationml/2006/main">
+  <p:cSld>
+    <p:spTree>
+      <p:nvGrpSpPr>
+        <p:cNvPr id="1" name=""/>
+        <p:cNvGrpSpPr/>
+        <p:nvPr/>
+      </p:nvGrpSpPr>
+      <p:grpSpPr>
+        <a:xfrm>
+          <a:off x="0" y="0"/>
+          <a:ext cx="0" cy="0"/>
+          <a:chOff x="0" y="0"/>
+          <a:chExt cx="0" cy="0"/>
+        </a:xfrm>
+      </p:grpSpPr>
+      <p:sp>
+        <p:nvSpPr>
+          <p:cNvPr id="2" name="Slide Image Placeholder 1"/>
+          <p:cNvSpPr>
+            <a:spLocks noGrp="1" noRot="1" noChangeAspect="1"/>
+          </p:cNvSpPr>
+          <p:nvPr>
+            <p:ph type="sldImg"/>
+          </p:nvPr>
+        </p:nvSpPr>
+        <p:spPr/>
+      </p:sp>
+      <p:sp>
+        <p:nvSpPr>
+          <p:cNvPr id="3" name="Notes Placeholder 2"/>
+          <p:cNvSpPr>
+            <a:spLocks noGrp="1"/>
+          </p:cNvSpPr>
+          <p:nvPr>
+            <p:ph type="body" idx="1"/>
+          </p:nvPr>
+        </p:nvSpPr>
+        <p:spPr/>
+        <p:txBody>
+          <a:bodyPr/>
+          <a:lstStyle/>
+          <a:p>
+            <a:r>
+              <a:rPr lang="en-US" dirty="0"/>
+              <a:t>A EDA fez quatro coisas pelo artigo. Delimitou o escopo: a geografia só pode ser do empregador. Deu a hipótese do trânsito. Expôs a limitação central — sem denominador de exposição, estamos medindo composição, não risco. E definiu o próximo passo: cruzar tipo com setor e buscar vínculos da RAIS.</a:t>
+            </a:r>
+            <a:endParaRPr lang="en-US" dirty="0"/>
+          </a:p>
+        </p:txBody>
+      </p:sp>
+      <p:sp>
+        <p:nvSpPr>
+          <p:cNvPr id="4" name="Slide Number Placeholder 3"/>
+          <p:cNvSpPr>
+            <a:spLocks noGrp="1"/>
+          </p:cNvSpPr>
+          <p:nvPr>
+            <p:ph type="sldNum" sz="quarter" idx="10"/>
+          </p:nvPr>
+        </p:nvSpPr>
+        <p:spPr/>
+        <p:txBody>
+          <a:bodyPr/>
+          <a:lstStyle/>
+          <a:p>
+            <a:fld id="{F7021451-1387-4CA6-816F-3879F97B5CBC}" type="slidenum">
+              <a:rPr lang="en-US"/>
+              <a:t>11</a:t>
             </a:fld>
             <a:endParaRPr lang="en-US"/>
           </a:p>
@@ -951,7 +1040,7 @@
           <a:p>
             <a:r>
               <a:rPr lang="en-US" dirty="0"/>
-              <a:t>Primeira decisão do REFINE. A UF do acidente tinha Maranhão em primeiro lugar e São Paulo ausente. Cruzando com a UF derivada do código IBGE do município, vimos que os rótulos estão trocados de forma sistemática, e que doze estados não têm rótulo nenhum. A coluna é irrecuperável — descartamos e usamos a do empregador.</a:t>
+              <a:t>Encontramos sete armadilhas. Elas têm uma coisa em comum, e é o que mais nos marcou: nenhuma delas quebra o código. Todas produzem resultado errado em silêncio. Por isso a exploração tomou mais tempo que a análise em si. Vou detalhar as duas mais graves, em âmbar.</a:t>
             </a:r>
             <a:endParaRPr lang="en-US" dirty="0"/>
           </a:p>
@@ -1039,7 +1128,7 @@
           <a:p>
             <a:r>
               <a:rPr lang="en-US" dirty="0"/>
-              <a:t>Segunda decisão. Os arquivos não são partições disjuntas: cada um cobre uma janela de mês de emissão, e as janelas se sobrepõem. Oito arquivos são republicação integral. Optamos por marcar a repetição numa coluna, em vez de apagar a linha — assim quem revisa consegue conferir a decisão.</a:t>
+              <a:t>Primeira decisão do REFINE. A UF do acidente tinha Maranhão em primeiro lugar e São Paulo ausente. Cruzando com a UF derivada do código IBGE do município, vimos que os rótulos estão trocados de forma sistemática, e que doze estados não têm rótulo nenhum. A coluna é irrecuperável — descartamos e usamos a do empregador.</a:t>
             </a:r>
             <a:endParaRPr lang="en-US" dirty="0"/>
           </a:p>
@@ -1127,7 +1216,7 @@
           <a:p>
             <a:r>
               <a:rPr lang="en-US" dirty="0"/>
-              <a:t>O PRODUCE entregou quatro coisas: a base consolidada, o pipeline que a reconstrói, um relatório descritivo que se regenera sozinho e um notebook que explica a consolidação. Tudo sustentado por 122 testes — cada decisão de limpeza tem um teste que a documenta.</a:t>
+              <a:t>Segunda decisão. Os arquivos não são partições disjuntas: cada um cobre uma janela de mês de emissão, e as janelas se sobrepõem. Oito arquivos são republicação integral. Optamos por marcar a repetição numa coluna, em vez de apagar a linha — assim quem revisa consegue conferir a decisão.</a:t>
             </a:r>
             <a:endParaRPr lang="en-US" dirty="0"/>
           </a:p>
@@ -1215,7 +1304,7 @@
           <a:p>
             <a:r>
               <a:rPr lang="en-US" dirty="0"/>
-              <a:t>As ferramentas foram basicamente as mesmas — Python, pandas — mas o papel mudou em cada fase. No EXPLORE, requisições HTTP leves para não baixar 1,8 GB só para ver um cabeçalho. No REFINE, pytest: cada decisão de limpeza virou teste. No PRODUCE, Parquet comprimido e Colab.</a:t>
+              <a:t>O PRODUCE entregou quatro coisas: a base consolidada, o pipeline que a reconstrói, um relatório descritivo que se regenera sozinho e um notebook que explica a consolidação. Tudo sustentado por 122 testes — cada decisão de limpeza tem um teste que a documenta.</a:t>
             </a:r>
             <a:endParaRPr lang="en-US" dirty="0"/>
           </a:p>
@@ -1303,7 +1392,7 @@
           <a:p>
             <a:r>
               <a:rPr lang="en-US" dirty="0"/>
-              <a:t>O achado principal. O trajeto é minoria dos acidentes, mas o mais letal — 2,7 vezes o típico. E o setor mais letal é o transporte rodoviário de carga, com quatro vezes a média geral. Duas análises independentes apontando para o trânsito. É a hipótese que vamos aprofundar.</a:t>
+              <a:t>As ferramentas foram basicamente as mesmas — Python, pandas — mas o papel mudou em cada fase. No EXPLORE, requisições HTTP leves para não baixar 1,8 GB só para ver um cabeçalho. No REFINE, pytest: cada decisão de limpeza virou teste. No PRODUCE, Parquet comprimido e Colab.</a:t>
             </a:r>
             <a:endParaRPr lang="en-US" dirty="0"/>
           </a:p>
@@ -2038,6 +2127,133 @@
 <file path=ppt/slides/slide10.xml><?xml version="1.0" encoding="utf-8"?>
 <p:sld xmlns:a="http://schemas.openxmlformats.org/drawingml/2006/main" xmlns:r="http://schemas.openxmlformats.org/officeDocument/2006/relationships" xmlns:p="http://schemas.openxmlformats.org/presentationml/2006/main">
   <p:cSld name="Slide 10">
+    <p:spTree>
+      <p:nvGrpSpPr>
+        <p:cNvPr id="1" name=""/>
+        <p:cNvGrpSpPr/>
+        <p:nvPr/>
+      </p:nvGrpSpPr>
+      <p:grpSpPr>
+        <a:xfrm>
+          <a:off x="0" y="0"/>
+          <a:ext cx="0" cy="0"/>
+          <a:chOff x="0" y="0"/>
+          <a:chExt cx="0" cy="0"/>
+        </a:xfrm>
+      </p:grpSpPr>
+      <p:sp>
+        <p:nvSpPr>
+          <p:cNvPr id="2" name="Text 0"/>
+          <p:cNvSpPr txBox="1"/>
+          <p:nvPr/>
+        </p:nvSpPr>
+        <p:spPr>
+          <a:xfrm>
+            <a:off x="502920" y="384048"/>
+            <a:ext cx="8138160" cy="566928"/>
+          </a:xfrm>
+          <a:prstGeom prst="rect">
+            <a:avLst/>
+          </a:prstGeom>
+          <a:noFill/>
+          <a:ln/>
+        </p:spPr>
+        <p:txBody>
+          <a:bodyPr wrap="square" lIns="0" tIns="0" rIns="0" bIns="0" rtlCol="0" anchor="ctr"/>
+          <a:lstStyle/>
+          <a:p>
+            <a:pPr algn="l" indent="0" marL="0">
+              <a:buNone/>
+            </a:pPr>
+            <a:r>
+              <a:rPr lang="en-US" sz="3000" b="1" dirty="0">
+                <a:solidFill>
+                  <a:srgbClr val="1C1C1E"/>
+                </a:solidFill>
+                <a:latin typeface="Cambria" pitchFamily="34" charset="0"/>
+                <a:ea typeface="Cambria" pitchFamily="34" charset="-122"/>
+                <a:cs typeface="Cambria" pitchFamily="34" charset="-120"/>
+              </a:rPr>
+              <a:t>Principais resultados: trajeto mata mais</a:t>
+            </a:r>
+            <a:endParaRPr lang="en-US" sz="3000" dirty="0"/>
+          </a:p>
+        </p:txBody>
+      </p:sp>
+      <p:pic>
+        <p:nvPicPr>
+          <p:cNvPr id="3" name="Image 0" descr="/home/user/ufpr-ppgcd-acidentes-no-trabalho/reports/apresentacao/figuras/letalidade.png">    </p:cNvPr>
+          <p:cNvPicPr>
+            <a:picLocks noChangeAspect="1"/>
+          </p:cNvPicPr>
+          <p:nvPr/>
+        </p:nvPicPr>
+        <p:blipFill>
+          <a:blip r:embed="rId1"/>
+          <a:stretch>
+            <a:fillRect/>
+          </a:stretch>
+        </p:blipFill>
+        <p:spPr>
+          <a:xfrm>
+            <a:off x="502920" y="1097280"/>
+            <a:ext cx="8138160" cy="3010788"/>
+          </a:xfrm>
+          <a:prstGeom prst="rect">
+            <a:avLst/>
+          </a:prstGeom>
+        </p:spPr>
+      </p:pic>
+      <p:sp>
+        <p:nvSpPr>
+          <p:cNvPr id="4" name="Text 1"/>
+          <p:cNvSpPr txBox="1"/>
+          <p:nvPr/>
+        </p:nvSpPr>
+        <p:spPr>
+          <a:xfrm>
+            <a:off x="502920" y="4160520"/>
+            <a:ext cx="8138160" cy="777240"/>
+          </a:xfrm>
+          <a:prstGeom prst="rect">
+            <a:avLst/>
+          </a:prstGeom>
+          <a:noFill/>
+          <a:ln/>
+        </p:spPr>
+        <p:txBody>
+          <a:bodyPr wrap="square" lIns="0" tIns="0" rIns="0" bIns="0" rtlCol="0" anchor="ctr"/>
+          <a:lstStyle/>
+          <a:p>
+            <a:pPr indent="0" marL="0">
+              <a:buNone/>
+            </a:pPr>
+            <a:r>
+              <a:rPr lang="en-US" sz="1350" dirty="0">
+                <a:solidFill>
+                  <a:srgbClr val="1C1C1E"/>
+                </a:solidFill>
+                <a:latin typeface="Calibri" pitchFamily="34" charset="0"/>
+                <a:ea typeface="Calibri" pitchFamily="34" charset="-122"/>
+                <a:cs typeface="Calibri" pitchFamily="34" charset="-120"/>
+              </a:rPr>
+              <a:t>O acidente de trajeto é 2,7× mais letal que o típico, apesar de 3,3× menos frequente. E o transporte rodoviário lidera entre os setores, com 4× a média. Duas análises independentes apontando para o mesmo mecanismo: o trânsito.</a:t>
+            </a:r>
+            <a:endParaRPr lang="en-US" sz="1350" dirty="0"/>
+          </a:p>
+        </p:txBody>
+      </p:sp>
+    </p:spTree>
+  </p:cSld>
+  <p:clrMapOvr>
+    <a:masterClrMapping/>
+  </p:clrMapOvr>
+</p:sld>
+</file>
+
+<file path=ppt/slides/slide11.xml><?xml version="1.0" encoding="utf-8"?>
+<p:sld xmlns:a="http://schemas.openxmlformats.org/drawingml/2006/main" xmlns:r="http://schemas.openxmlformats.org/officeDocument/2006/relationships" xmlns:p="http://schemas.openxmlformats.org/presentationml/2006/main">
+  <p:cSld name="Slide 11">
     <p:bg>
       <p:bgPr>
         <a:solidFill>
@@ -3972,45 +4188,1015 @@
                 <a:ea typeface="Cambria" pitchFamily="34" charset="-122"/>
                 <a:cs typeface="Cambria" pitchFamily="34" charset="-120"/>
               </a:rPr>
-              <a:t>REFINE — a coluna que mentia</a:t>
+              <a:t>As 7 armadilhas que encontramos</a:t>
             </a:r>
             <a:endParaRPr lang="en-US" sz="3000" dirty="0"/>
           </a:p>
         </p:txBody>
       </p:sp>
-      <p:pic>
-        <p:nvPicPr>
-          <p:cNvPr id="3" name="Image 0" descr="/home/user/ufpr-ppgcd-acidentes-no-trabalho/reports/apresentacao/figuras/uf-trocada.png">    </p:cNvPr>
-          <p:cNvPicPr>
-            <a:picLocks noChangeAspect="1"/>
-          </p:cNvPicPr>
-          <p:nvPr/>
-        </p:nvPicPr>
-        <p:blipFill>
-          <a:blip r:embed="rId1"/>
-          <a:stretch>
-            <a:fillRect/>
-          </a:stretch>
-        </p:blipFill>
-        <p:spPr>
-          <a:xfrm>
-            <a:off x="502920" y="1078992"/>
-            <a:ext cx="7863840" cy="3040928"/>
-          </a:xfrm>
-          <a:prstGeom prst="rect">
-            <a:avLst/>
-          </a:prstGeom>
-        </p:spPr>
-      </p:pic>
-      <p:sp>
-        <p:nvSpPr>
-          <p:cNvPr id="4" name="Text 1"/>
-          <p:cNvSpPr txBox="1"/>
-          <p:nvPr/>
-        </p:nvSpPr>
-        <p:spPr>
-          <a:xfrm>
-            <a:off x="502920" y="4261104"/>
+      <p:sp>
+        <p:nvSpPr>
+          <p:cNvPr id="3" name="Shape 1"/>
+          <p:cNvSpPr/>
+          <p:nvPr/>
+        </p:nvSpPr>
+        <p:spPr>
+          <a:xfrm>
+            <a:off x="502920" y="1188720"/>
+            <a:ext cx="292608" cy="292608"/>
+          </a:xfrm>
+          <a:prstGeom prst="ellipse">
+            <a:avLst/>
+          </a:prstGeom>
+          <a:solidFill>
+            <a:srgbClr val="EB6834"/>
+          </a:solidFill>
+          <a:ln w="12700">
+            <a:solidFill>
+              <a:srgbClr val="EB6834"/>
+            </a:solidFill>
+            <a:prstDash val="solid"/>
+          </a:ln>
+        </p:spPr>
+      </p:sp>
+      <p:sp>
+        <p:nvSpPr>
+          <p:cNvPr id="4" name="Text 2"/>
+          <p:cNvSpPr txBox="1"/>
+          <p:nvPr/>
+        </p:nvSpPr>
+        <p:spPr>
+          <a:xfrm>
+            <a:off x="502920" y="1188720"/>
+            <a:ext cx="292608" cy="292608"/>
+          </a:xfrm>
+          <a:prstGeom prst="rect">
+            <a:avLst/>
+          </a:prstGeom>
+          <a:noFill/>
+          <a:ln/>
+        </p:spPr>
+        <p:txBody>
+          <a:bodyPr wrap="square" lIns="0" tIns="0" rIns="0" bIns="0" rtlCol="0" anchor="ctr"/>
+          <a:lstStyle/>
+          <a:p>
+            <a:pPr algn="ctr" indent="0" marL="0">
+              <a:buNone/>
+            </a:pPr>
+            <a:r>
+              <a:rPr lang="en-US" sz="1400" b="1" dirty="0">
+                <a:solidFill>
+                  <a:srgbClr val="FFFFFF"/>
+                </a:solidFill>
+                <a:latin typeface="Calibri" pitchFamily="34" charset="0"/>
+                <a:ea typeface="Calibri" pitchFamily="34" charset="-122"/>
+                <a:cs typeface="Calibri" pitchFamily="34" charset="-120"/>
+              </a:rPr>
+              <a:t>1</a:t>
+            </a:r>
+            <a:endParaRPr lang="en-US" sz="1400" dirty="0"/>
+          </a:p>
+        </p:txBody>
+      </p:sp>
+      <p:sp>
+        <p:nvSpPr>
+          <p:cNvPr id="5" name="Text 3"/>
+          <p:cNvSpPr txBox="1"/>
+          <p:nvPr/>
+        </p:nvSpPr>
+        <p:spPr>
+          <a:xfrm>
+            <a:off x="923544" y="1170432"/>
+            <a:ext cx="3566160" cy="274320"/>
+          </a:xfrm>
+          <a:prstGeom prst="rect">
+            <a:avLst/>
+          </a:prstGeom>
+          <a:noFill/>
+          <a:ln/>
+        </p:spPr>
+        <p:txBody>
+          <a:bodyPr wrap="square" lIns="0" tIns="0" rIns="0" bIns="0" rtlCol="0" anchor="ctr"/>
+          <a:lstStyle/>
+          <a:p>
+            <a:pPr indent="0" marL="0">
+              <a:buNone/>
+            </a:pPr>
+            <a:r>
+              <a:rPr lang="en-US" sz="1300" b="1" dirty="0">
+                <a:solidFill>
+                  <a:srgbClr val="1C1C1E"/>
+                </a:solidFill>
+                <a:latin typeface="Calibri" pitchFamily="34" charset="0"/>
+                <a:ea typeface="Calibri" pitchFamily="34" charset="-122"/>
+                <a:cs typeface="Calibri" pitchFamily="34" charset="-120"/>
+              </a:rPr>
+              <a:t>Os arquivos se sobrepõem</a:t>
+            </a:r>
+            <a:endParaRPr lang="en-US" sz="1300" dirty="0"/>
+          </a:p>
+        </p:txBody>
+      </p:sp>
+      <p:sp>
+        <p:nvSpPr>
+          <p:cNvPr id="6" name="Text 4"/>
+          <p:cNvSpPr txBox="1"/>
+          <p:nvPr/>
+        </p:nvSpPr>
+        <p:spPr>
+          <a:xfrm>
+            <a:off x="923544" y="1435608"/>
+            <a:ext cx="3566160" cy="402336"/>
+          </a:xfrm>
+          <a:prstGeom prst="rect">
+            <a:avLst/>
+          </a:prstGeom>
+          <a:noFill/>
+          <a:ln/>
+        </p:spPr>
+        <p:txBody>
+          <a:bodyPr wrap="square" lIns="0" tIns="0" rIns="0" bIns="0" rtlCol="0" anchor="ctr"/>
+          <a:lstStyle/>
+          <a:p>
+            <a:pPr indent="0" marL="0">
+              <a:buNone/>
+            </a:pPr>
+            <a:r>
+              <a:rPr lang="en-US" sz="1150" dirty="0">
+                <a:solidFill>
+                  <a:srgbClr val="6B6A66"/>
+                </a:solidFill>
+                <a:latin typeface="Calibri" pitchFamily="34" charset="0"/>
+                <a:ea typeface="Calibri" pitchFamily="34" charset="-122"/>
+                <a:cs typeface="Calibri" pitchFamily="34" charset="-120"/>
+              </a:rPr>
+              <a:t>11,7% das linhas são republicação</a:t>
+            </a:r>
+            <a:endParaRPr lang="en-US" sz="1150" dirty="0"/>
+          </a:p>
+        </p:txBody>
+      </p:sp>
+      <p:sp>
+        <p:nvSpPr>
+          <p:cNvPr id="7" name="Shape 5"/>
+          <p:cNvSpPr/>
+          <p:nvPr/>
+        </p:nvSpPr>
+        <p:spPr>
+          <a:xfrm>
+            <a:off x="502920" y="1938528"/>
+            <a:ext cx="292608" cy="292608"/>
+          </a:xfrm>
+          <a:prstGeom prst="ellipse">
+            <a:avLst/>
+          </a:prstGeom>
+          <a:solidFill>
+            <a:srgbClr val="EB6834"/>
+          </a:solidFill>
+          <a:ln w="12700">
+            <a:solidFill>
+              <a:srgbClr val="EB6834"/>
+            </a:solidFill>
+            <a:prstDash val="solid"/>
+          </a:ln>
+        </p:spPr>
+      </p:sp>
+      <p:sp>
+        <p:nvSpPr>
+          <p:cNvPr id="8" name="Text 6"/>
+          <p:cNvSpPr txBox="1"/>
+          <p:nvPr/>
+        </p:nvSpPr>
+        <p:spPr>
+          <a:xfrm>
+            <a:off x="502920" y="1938528"/>
+            <a:ext cx="292608" cy="292608"/>
+          </a:xfrm>
+          <a:prstGeom prst="rect">
+            <a:avLst/>
+          </a:prstGeom>
+          <a:noFill/>
+          <a:ln/>
+        </p:spPr>
+        <p:txBody>
+          <a:bodyPr wrap="square" lIns="0" tIns="0" rIns="0" bIns="0" rtlCol="0" anchor="ctr"/>
+          <a:lstStyle/>
+          <a:p>
+            <a:pPr algn="ctr" indent="0" marL="0">
+              <a:buNone/>
+            </a:pPr>
+            <a:r>
+              <a:rPr lang="en-US" sz="1400" b="1" dirty="0">
+                <a:solidFill>
+                  <a:srgbClr val="FFFFFF"/>
+                </a:solidFill>
+                <a:latin typeface="Calibri" pitchFamily="34" charset="0"/>
+                <a:ea typeface="Calibri" pitchFamily="34" charset="-122"/>
+                <a:cs typeface="Calibri" pitchFamily="34" charset="-120"/>
+              </a:rPr>
+              <a:t>2</a:t>
+            </a:r>
+            <a:endParaRPr lang="en-US" sz="1400" dirty="0"/>
+          </a:p>
+        </p:txBody>
+      </p:sp>
+      <p:sp>
+        <p:nvSpPr>
+          <p:cNvPr id="9" name="Text 7"/>
+          <p:cNvSpPr txBox="1"/>
+          <p:nvPr/>
+        </p:nvSpPr>
+        <p:spPr>
+          <a:xfrm>
+            <a:off x="923544" y="1920240"/>
+            <a:ext cx="3566160" cy="274320"/>
+          </a:xfrm>
+          <a:prstGeom prst="rect">
+            <a:avLst/>
+          </a:prstGeom>
+          <a:noFill/>
+          <a:ln/>
+        </p:spPr>
+        <p:txBody>
+          <a:bodyPr wrap="square" lIns="0" tIns="0" rIns="0" bIns="0" rtlCol="0" anchor="ctr"/>
+          <a:lstStyle/>
+          <a:p>
+            <a:pPr indent="0" marL="0">
+              <a:buNone/>
+            </a:pPr>
+            <a:r>
+              <a:rPr lang="en-US" sz="1300" b="1" dirty="0">
+                <a:solidFill>
+                  <a:srgbClr val="1C1C1E"/>
+                </a:solidFill>
+                <a:latin typeface="Calibri" pitchFamily="34" charset="0"/>
+                <a:ea typeface="Calibri" pitchFamily="34" charset="-122"/>
+                <a:cs typeface="Calibri" pitchFamily="34" charset="-120"/>
+              </a:rPr>
+              <a:t>A UF do acidente está trocada</a:t>
+            </a:r>
+            <a:endParaRPr lang="en-US" sz="1300" dirty="0"/>
+          </a:p>
+        </p:txBody>
+      </p:sp>
+      <p:sp>
+        <p:nvSpPr>
+          <p:cNvPr id="10" name="Text 8"/>
+          <p:cNvSpPr txBox="1"/>
+          <p:nvPr/>
+        </p:nvSpPr>
+        <p:spPr>
+          <a:xfrm>
+            <a:off x="923544" y="2185416"/>
+            <a:ext cx="3566160" cy="402336"/>
+          </a:xfrm>
+          <a:prstGeom prst="rect">
+            <a:avLst/>
+          </a:prstGeom>
+          <a:noFill/>
+          <a:ln/>
+        </p:spPr>
+        <p:txBody>
+          <a:bodyPr wrap="square" lIns="0" tIns="0" rIns="0" bIns="0" rtlCol="0" anchor="ctr"/>
+          <a:lstStyle/>
+          <a:p>
+            <a:pPr indent="0" marL="0">
+              <a:buNone/>
+            </a:pPr>
+            <a:r>
+              <a:rPr lang="en-US" sz="1150" dirty="0">
+                <a:solidFill>
+                  <a:srgbClr val="6B6A66"/>
+                </a:solidFill>
+                <a:latin typeface="Calibri" pitchFamily="34" charset="0"/>
+                <a:ea typeface="Calibri" pitchFamily="34" charset="-122"/>
+                <a:cs typeface="Calibri" pitchFamily="34" charset="-120"/>
+              </a:rPr>
+              <a:t>rótulos errados; 12 UFs sem rótulo algum</a:t>
+            </a:r>
+            <a:endParaRPr lang="en-US" sz="1150" dirty="0"/>
+          </a:p>
+        </p:txBody>
+      </p:sp>
+      <p:sp>
+        <p:nvSpPr>
+          <p:cNvPr id="11" name="Shape 9"/>
+          <p:cNvSpPr/>
+          <p:nvPr/>
+        </p:nvSpPr>
+        <p:spPr>
+          <a:xfrm>
+            <a:off x="502920" y="2688336"/>
+            <a:ext cx="292608" cy="292608"/>
+          </a:xfrm>
+          <a:prstGeom prst="ellipse">
+            <a:avLst/>
+          </a:prstGeom>
+          <a:solidFill>
+            <a:srgbClr val="2A78D6"/>
+          </a:solidFill>
+          <a:ln w="12700">
+            <a:solidFill>
+              <a:srgbClr val="2A78D6"/>
+            </a:solidFill>
+            <a:prstDash val="solid"/>
+          </a:ln>
+        </p:spPr>
+      </p:sp>
+      <p:sp>
+        <p:nvSpPr>
+          <p:cNvPr id="12" name="Text 10"/>
+          <p:cNvSpPr txBox="1"/>
+          <p:nvPr/>
+        </p:nvSpPr>
+        <p:spPr>
+          <a:xfrm>
+            <a:off x="502920" y="2688336"/>
+            <a:ext cx="292608" cy="292608"/>
+          </a:xfrm>
+          <a:prstGeom prst="rect">
+            <a:avLst/>
+          </a:prstGeom>
+          <a:noFill/>
+          <a:ln/>
+        </p:spPr>
+        <p:txBody>
+          <a:bodyPr wrap="square" lIns="0" tIns="0" rIns="0" bIns="0" rtlCol="0" anchor="ctr"/>
+          <a:lstStyle/>
+          <a:p>
+            <a:pPr algn="ctr" indent="0" marL="0">
+              <a:buNone/>
+            </a:pPr>
+            <a:r>
+              <a:rPr lang="en-US" sz="1400" b="1" dirty="0">
+                <a:solidFill>
+                  <a:srgbClr val="FFFFFF"/>
+                </a:solidFill>
+                <a:latin typeface="Calibri" pitchFamily="34" charset="0"/>
+                <a:ea typeface="Calibri" pitchFamily="34" charset="-122"/>
+                <a:cs typeface="Calibri" pitchFamily="34" charset="-120"/>
+              </a:rPr>
+              <a:t>3</a:t>
+            </a:r>
+            <a:endParaRPr lang="en-US" sz="1400" dirty="0"/>
+          </a:p>
+        </p:txBody>
+      </p:sp>
+      <p:sp>
+        <p:nvSpPr>
+          <p:cNvPr id="13" name="Text 11"/>
+          <p:cNvSpPr txBox="1"/>
+          <p:nvPr/>
+        </p:nvSpPr>
+        <p:spPr>
+          <a:xfrm>
+            <a:off x="923544" y="2670048"/>
+            <a:ext cx="3566160" cy="274320"/>
+          </a:xfrm>
+          <a:prstGeom prst="rect">
+            <a:avLst/>
+          </a:prstGeom>
+          <a:noFill/>
+          <a:ln/>
+        </p:spPr>
+        <p:txBody>
+          <a:bodyPr wrap="square" lIns="0" tIns="0" rIns="0" bIns="0" rtlCol="0" anchor="ctr"/>
+          <a:lstStyle/>
+          <a:p>
+            <a:pPr indent="0" marL="0">
+              <a:buNone/>
+            </a:pPr>
+            <a:r>
+              <a:rPr lang="en-US" sz="1300" b="1" dirty="0">
+                <a:solidFill>
+                  <a:srgbClr val="1C1C1E"/>
+                </a:solidFill>
+                <a:latin typeface="Calibri" pitchFamily="34" charset="0"/>
+                <a:ea typeface="Calibri" pitchFamily="34" charset="-122"/>
+                <a:cs typeface="Calibri" pitchFamily="34" charset="-120"/>
+              </a:rPr>
+              <a:t>Rótulos de coluna que mentem</a:t>
+            </a:r>
+            <a:endParaRPr lang="en-US" sz="1300" dirty="0"/>
+          </a:p>
+        </p:txBody>
+      </p:sp>
+      <p:sp>
+        <p:nvSpPr>
+          <p:cNvPr id="14" name="Text 12"/>
+          <p:cNvSpPr txBox="1"/>
+          <p:nvPr/>
+        </p:nvSpPr>
+        <p:spPr>
+          <a:xfrm>
+            <a:off x="923544" y="2935224"/>
+            <a:ext cx="3566160" cy="402336"/>
+          </a:xfrm>
+          <a:prstGeom prst="rect">
+            <a:avLst/>
+          </a:prstGeom>
+          <a:noFill/>
+          <a:ln/>
+        </p:spPr>
+        <p:txBody>
+          <a:bodyPr wrap="square" lIns="0" tIns="0" rIns="0" bIns="0" rtlCol="0" anchor="ctr"/>
+          <a:lstStyle/>
+          <a:p>
+            <a:pPr indent="0" marL="0">
+              <a:buNone/>
+            </a:pPr>
+            <a:r>
+              <a:rPr lang="en-US" sz="1150" dirty="0">
+                <a:solidFill>
+                  <a:srgbClr val="6B6A66"/>
+                </a:solidFill>
+                <a:latin typeface="Calibri" pitchFamily="34" charset="0"/>
+                <a:ea typeface="Calibri" pitchFamily="34" charset="-122"/>
+                <a:cs typeface="Calibri" pitchFamily="34" charset="-120"/>
+              </a:rPr>
+              <a:t>“Data Acidente” trazendo outro conteúdo</a:t>
+            </a:r>
+            <a:endParaRPr lang="en-US" sz="1150" dirty="0"/>
+          </a:p>
+        </p:txBody>
+      </p:sp>
+      <p:sp>
+        <p:nvSpPr>
+          <p:cNvPr id="15" name="Shape 13"/>
+          <p:cNvSpPr/>
+          <p:nvPr/>
+        </p:nvSpPr>
+        <p:spPr>
+          <a:xfrm>
+            <a:off x="502920" y="3438144"/>
+            <a:ext cx="292608" cy="292608"/>
+          </a:xfrm>
+          <a:prstGeom prst="ellipse">
+            <a:avLst/>
+          </a:prstGeom>
+          <a:solidFill>
+            <a:srgbClr val="2A78D6"/>
+          </a:solidFill>
+          <a:ln w="12700">
+            <a:solidFill>
+              <a:srgbClr val="2A78D6"/>
+            </a:solidFill>
+            <a:prstDash val="solid"/>
+          </a:ln>
+        </p:spPr>
+      </p:sp>
+      <p:sp>
+        <p:nvSpPr>
+          <p:cNvPr id="16" name="Text 14"/>
+          <p:cNvSpPr txBox="1"/>
+          <p:nvPr/>
+        </p:nvSpPr>
+        <p:spPr>
+          <a:xfrm>
+            <a:off x="502920" y="3438144"/>
+            <a:ext cx="292608" cy="292608"/>
+          </a:xfrm>
+          <a:prstGeom prst="rect">
+            <a:avLst/>
+          </a:prstGeom>
+          <a:noFill/>
+          <a:ln/>
+        </p:spPr>
+        <p:txBody>
+          <a:bodyPr wrap="square" lIns="0" tIns="0" rIns="0" bIns="0" rtlCol="0" anchor="ctr"/>
+          <a:lstStyle/>
+          <a:p>
+            <a:pPr algn="ctr" indent="0" marL="0">
+              <a:buNone/>
+            </a:pPr>
+            <a:r>
+              <a:rPr lang="en-US" sz="1400" b="1" dirty="0">
+                <a:solidFill>
+                  <a:srgbClr val="FFFFFF"/>
+                </a:solidFill>
+                <a:latin typeface="Calibri" pitchFamily="34" charset="0"/>
+                <a:ea typeface="Calibri" pitchFamily="34" charset="-122"/>
+                <a:cs typeface="Calibri" pitchFamily="34" charset="-120"/>
+              </a:rPr>
+              <a:t>4</a:t>
+            </a:r>
+            <a:endParaRPr lang="en-US" sz="1400" dirty="0"/>
+          </a:p>
+        </p:txBody>
+      </p:sp>
+      <p:sp>
+        <p:nvSpPr>
+          <p:cNvPr id="17" name="Text 15"/>
+          <p:cNvSpPr txBox="1"/>
+          <p:nvPr/>
+        </p:nvSpPr>
+        <p:spPr>
+          <a:xfrm>
+            <a:off x="923544" y="3419856"/>
+            <a:ext cx="3566160" cy="274320"/>
+          </a:xfrm>
+          <a:prstGeom prst="rect">
+            <a:avLst/>
+          </a:prstGeom>
+          <a:noFill/>
+          <a:ln/>
+        </p:spPr>
+        <p:txBody>
+          <a:bodyPr wrap="square" lIns="0" tIns="0" rIns="0" bIns="0" rtlCol="0" anchor="ctr"/>
+          <a:lstStyle/>
+          <a:p>
+            <a:pPr indent="0" marL="0">
+              <a:buNone/>
+            </a:pPr>
+            <a:r>
+              <a:rPr lang="en-US" sz="1300" b="1" dirty="0">
+                <a:solidFill>
+                  <a:srgbClr val="1C1C1E"/>
+                </a:solidFill>
+                <a:latin typeface="Calibri" pitchFamily="34" charset="0"/>
+                <a:ea typeface="Calibri" pitchFamily="34" charset="-122"/>
+                <a:cs typeface="Calibri" pitchFamily="34" charset="-120"/>
+              </a:rPr>
+              <a:t>O dicionário erra a data</a:t>
+            </a:r>
+            <a:endParaRPr lang="en-US" sz="1300" dirty="0"/>
+          </a:p>
+        </p:txBody>
+      </p:sp>
+      <p:sp>
+        <p:nvSpPr>
+          <p:cNvPr id="18" name="Text 16"/>
+          <p:cNvSpPr txBox="1"/>
+          <p:nvPr/>
+        </p:nvSpPr>
+        <p:spPr>
+          <a:xfrm>
+            <a:off x="923544" y="3685032"/>
+            <a:ext cx="3566160" cy="402336"/>
+          </a:xfrm>
+          <a:prstGeom prst="rect">
+            <a:avLst/>
+          </a:prstGeom>
+          <a:noFill/>
+          <a:ln/>
+        </p:spPr>
+        <p:txBody>
+          <a:bodyPr wrap="square" lIns="0" tIns="0" rIns="0" bIns="0" rtlCol="0" anchor="ctr"/>
+          <a:lstStyle/>
+          <a:p>
+            <a:pPr indent="0" marL="0">
+              <a:buNone/>
+            </a:pPr>
+            <a:r>
+              <a:rPr lang="en-US" sz="1150" dirty="0">
+                <a:solidFill>
+                  <a:srgbClr val="6B6A66"/>
+                </a:solidFill>
+                <a:latin typeface="Calibri" pitchFamily="34" charset="0"/>
+                <a:ea typeface="Calibri" pitchFamily="34" charset="-122"/>
+                <a:cs typeface="Calibri" pitchFamily="34" charset="-120"/>
+              </a:rPr>
+              <a:t>é DD/MM/AAAA, não o AAAAMMDD publicado</a:t>
+            </a:r>
+            <a:endParaRPr lang="en-US" sz="1150" dirty="0"/>
+          </a:p>
+        </p:txBody>
+      </p:sp>
+      <p:sp>
+        <p:nvSpPr>
+          <p:cNvPr id="19" name="Shape 17"/>
+          <p:cNvSpPr/>
+          <p:nvPr/>
+        </p:nvSpPr>
+        <p:spPr>
+          <a:xfrm>
+            <a:off x="4754880" y="1188720"/>
+            <a:ext cx="292608" cy="292608"/>
+          </a:xfrm>
+          <a:prstGeom prst="ellipse">
+            <a:avLst/>
+          </a:prstGeom>
+          <a:solidFill>
+            <a:srgbClr val="2A78D6"/>
+          </a:solidFill>
+          <a:ln w="12700">
+            <a:solidFill>
+              <a:srgbClr val="2A78D6"/>
+            </a:solidFill>
+            <a:prstDash val="solid"/>
+          </a:ln>
+        </p:spPr>
+      </p:sp>
+      <p:sp>
+        <p:nvSpPr>
+          <p:cNvPr id="20" name="Text 18"/>
+          <p:cNvSpPr txBox="1"/>
+          <p:nvPr/>
+        </p:nvSpPr>
+        <p:spPr>
+          <a:xfrm>
+            <a:off x="4754880" y="1188720"/>
+            <a:ext cx="292608" cy="292608"/>
+          </a:xfrm>
+          <a:prstGeom prst="rect">
+            <a:avLst/>
+          </a:prstGeom>
+          <a:noFill/>
+          <a:ln/>
+        </p:spPr>
+        <p:txBody>
+          <a:bodyPr wrap="square" lIns="0" tIns="0" rIns="0" bIns="0" rtlCol="0" anchor="ctr"/>
+          <a:lstStyle/>
+          <a:p>
+            <a:pPr algn="ctr" indent="0" marL="0">
+              <a:buNone/>
+            </a:pPr>
+            <a:r>
+              <a:rPr lang="en-US" sz="1400" b="1" dirty="0">
+                <a:solidFill>
+                  <a:srgbClr val="FFFFFF"/>
+                </a:solidFill>
+                <a:latin typeface="Calibri" pitchFamily="34" charset="0"/>
+                <a:ea typeface="Calibri" pitchFamily="34" charset="-122"/>
+                <a:cs typeface="Calibri" pitchFamily="34" charset="-120"/>
+              </a:rPr>
+              <a:t>5</a:t>
+            </a:r>
+            <a:endParaRPr lang="en-US" sz="1400" dirty="0"/>
+          </a:p>
+        </p:txBody>
+      </p:sp>
+      <p:sp>
+        <p:nvSpPr>
+          <p:cNvPr id="21" name="Text 19"/>
+          <p:cNvSpPr txBox="1"/>
+          <p:nvPr/>
+        </p:nvSpPr>
+        <p:spPr>
+          <a:xfrm>
+            <a:off x="5175504" y="1170432"/>
+            <a:ext cx="3566160" cy="274320"/>
+          </a:xfrm>
+          <a:prstGeom prst="rect">
+            <a:avLst/>
+          </a:prstGeom>
+          <a:noFill/>
+          <a:ln/>
+        </p:spPr>
+        <p:txBody>
+          <a:bodyPr wrap="square" lIns="0" tIns="0" rIns="0" bIns="0" rtlCol="0" anchor="ctr"/>
+          <a:lstStyle/>
+          <a:p>
+            <a:pPr indent="0" marL="0">
+              <a:buNone/>
+            </a:pPr>
+            <a:r>
+              <a:rPr lang="en-US" sz="1300" b="1" dirty="0">
+                <a:solidFill>
+                  <a:srgbClr val="1C1C1E"/>
+                </a:solidFill>
+                <a:latin typeface="Calibri" pitchFamily="34" charset="0"/>
+                <a:ea typeface="Calibri" pitchFamily="34" charset="-122"/>
+                <a:cs typeface="Calibri" pitchFamily="34" charset="-120"/>
+              </a:rPr>
+              <a:t>Encoding misto</a:t>
+            </a:r>
+            <a:endParaRPr lang="en-US" sz="1300" dirty="0"/>
+          </a:p>
+        </p:txBody>
+      </p:sp>
+      <p:sp>
+        <p:nvSpPr>
+          <p:cNvPr id="22" name="Text 20"/>
+          <p:cNvSpPr txBox="1"/>
+          <p:nvPr/>
+        </p:nvSpPr>
+        <p:spPr>
+          <a:xfrm>
+            <a:off x="5175504" y="1435608"/>
+            <a:ext cx="3566160" cy="402336"/>
+          </a:xfrm>
+          <a:prstGeom prst="rect">
+            <a:avLst/>
+          </a:prstGeom>
+          <a:noFill/>
+          <a:ln/>
+        </p:spPr>
+        <p:txBody>
+          <a:bodyPr wrap="square" lIns="0" tIns="0" rIns="0" bIns="0" rtlCol="0" anchor="ctr"/>
+          <a:lstStyle/>
+          <a:p>
+            <a:pPr indent="0" marL="0">
+              <a:buNone/>
+            </a:pPr>
+            <a:r>
+              <a:rPr lang="en-US" sz="1150" dirty="0">
+                <a:solidFill>
+                  <a:srgbClr val="6B6A66"/>
+                </a:solidFill>
+                <a:latin typeface="Calibri" pitchFamily="34" charset="0"/>
+                <a:ea typeface="Calibri" pitchFamily="34" charset="-122"/>
+                <a:cs typeface="Calibri" pitchFamily="34" charset="-120"/>
+              </a:rPr>
+              <a:t>3 arquivos UTF-8 entre 58 em latin-1</a:t>
+            </a:r>
+            <a:endParaRPr lang="en-US" sz="1150" dirty="0"/>
+          </a:p>
+        </p:txBody>
+      </p:sp>
+      <p:sp>
+        <p:nvSpPr>
+          <p:cNvPr id="23" name="Shape 21"/>
+          <p:cNvSpPr/>
+          <p:nvPr/>
+        </p:nvSpPr>
+        <p:spPr>
+          <a:xfrm>
+            <a:off x="4754880" y="1938528"/>
+            <a:ext cx="292608" cy="292608"/>
+          </a:xfrm>
+          <a:prstGeom prst="ellipse">
+            <a:avLst/>
+          </a:prstGeom>
+          <a:solidFill>
+            <a:srgbClr val="2A78D6"/>
+          </a:solidFill>
+          <a:ln w="12700">
+            <a:solidFill>
+              <a:srgbClr val="2A78D6"/>
+            </a:solidFill>
+            <a:prstDash val="solid"/>
+          </a:ln>
+        </p:spPr>
+      </p:sp>
+      <p:sp>
+        <p:nvSpPr>
+          <p:cNvPr id="24" name="Text 22"/>
+          <p:cNvSpPr txBox="1"/>
+          <p:nvPr/>
+        </p:nvSpPr>
+        <p:spPr>
+          <a:xfrm>
+            <a:off x="4754880" y="1938528"/>
+            <a:ext cx="292608" cy="292608"/>
+          </a:xfrm>
+          <a:prstGeom prst="rect">
+            <a:avLst/>
+          </a:prstGeom>
+          <a:noFill/>
+          <a:ln/>
+        </p:spPr>
+        <p:txBody>
+          <a:bodyPr wrap="square" lIns="0" tIns="0" rIns="0" bIns="0" rtlCol="0" anchor="ctr"/>
+          <a:lstStyle/>
+          <a:p>
+            <a:pPr algn="ctr" indent="0" marL="0">
+              <a:buNone/>
+            </a:pPr>
+            <a:r>
+              <a:rPr lang="en-US" sz="1400" b="1" dirty="0">
+                <a:solidFill>
+                  <a:srgbClr val="FFFFFF"/>
+                </a:solidFill>
+                <a:latin typeface="Calibri" pitchFamily="34" charset="0"/>
+                <a:ea typeface="Calibri" pitchFamily="34" charset="-122"/>
+                <a:cs typeface="Calibri" pitchFamily="34" charset="-120"/>
+              </a:rPr>
+              <a:t>6</a:t>
+            </a:r>
+            <a:endParaRPr lang="en-US" sz="1400" dirty="0"/>
+          </a:p>
+        </p:txBody>
+      </p:sp>
+      <p:sp>
+        <p:nvSpPr>
+          <p:cNvPr id="25" name="Text 23"/>
+          <p:cNvSpPr txBox="1"/>
+          <p:nvPr/>
+        </p:nvSpPr>
+        <p:spPr>
+          <a:xfrm>
+            <a:off x="5175504" y="1920240"/>
+            <a:ext cx="3566160" cy="274320"/>
+          </a:xfrm>
+          <a:prstGeom prst="rect">
+            <a:avLst/>
+          </a:prstGeom>
+          <a:noFill/>
+          <a:ln/>
+        </p:spPr>
+        <p:txBody>
+          <a:bodyPr wrap="square" lIns="0" tIns="0" rIns="0" bIns="0" rtlCol="0" anchor="ctr"/>
+          <a:lstStyle/>
+          <a:p>
+            <a:pPr indent="0" marL="0">
+              <a:buNone/>
+            </a:pPr>
+            <a:r>
+              <a:rPr lang="en-US" sz="1300" b="1" dirty="0">
+                <a:solidFill>
+                  <a:srgbClr val="1C1C1E"/>
+                </a:solidFill>
+                <a:latin typeface="Calibri" pitchFamily="34" charset="0"/>
+                <a:ea typeface="Calibri" pitchFamily="34" charset="-122"/>
+                <a:cs typeface="Calibri" pitchFamily="34" charset="-120"/>
+              </a:rPr>
+              <a:t>Descrições truncadas</a:t>
+            </a:r>
+            <a:endParaRPr lang="en-US" sz="1300" dirty="0"/>
+          </a:p>
+        </p:txBody>
+      </p:sp>
+      <p:sp>
+        <p:nvSpPr>
+          <p:cNvPr id="26" name="Text 24"/>
+          <p:cNvSpPr txBox="1"/>
+          <p:nvPr/>
+        </p:nvSpPr>
+        <p:spPr>
+          <a:xfrm>
+            <a:off x="5175504" y="2185416"/>
+            <a:ext cx="3566160" cy="402336"/>
+          </a:xfrm>
+          <a:prstGeom prst="rect">
+            <a:avLst/>
+          </a:prstGeom>
+          <a:noFill/>
+          <a:ln/>
+        </p:spPr>
+        <p:txBody>
+          <a:bodyPr wrap="square" lIns="0" tIns="0" rIns="0" bIns="0" rtlCol="0" anchor="ctr"/>
+          <a:lstStyle/>
+          <a:p>
+            <a:pPr indent="0" marL="0">
+              <a:buNone/>
+            </a:pPr>
+            <a:r>
+              <a:rPr lang="en-US" sz="1150" dirty="0">
+                <a:solidFill>
+                  <a:srgbClr val="6B6A66"/>
+                </a:solidFill>
+                <a:latin typeface="Calibri" pitchFamily="34" charset="0"/>
+                <a:ea typeface="Calibri" pitchFamily="34" charset="-122"/>
+                <a:cs typeface="Calibri" pitchFamily="34" charset="-120"/>
+              </a:rPr>
+              <a:t>20 caracteres partem 84,7% dos CNAE em dois</a:t>
+            </a:r>
+            <a:endParaRPr lang="en-US" sz="1150" dirty="0"/>
+          </a:p>
+        </p:txBody>
+      </p:sp>
+      <p:sp>
+        <p:nvSpPr>
+          <p:cNvPr id="27" name="Shape 25"/>
+          <p:cNvSpPr/>
+          <p:nvPr/>
+        </p:nvSpPr>
+        <p:spPr>
+          <a:xfrm>
+            <a:off x="4754880" y="2688336"/>
+            <a:ext cx="292608" cy="292608"/>
+          </a:xfrm>
+          <a:prstGeom prst="ellipse">
+            <a:avLst/>
+          </a:prstGeom>
+          <a:solidFill>
+            <a:srgbClr val="2A78D6"/>
+          </a:solidFill>
+          <a:ln w="12700">
+            <a:solidFill>
+              <a:srgbClr val="2A78D6"/>
+            </a:solidFill>
+            <a:prstDash val="solid"/>
+          </a:ln>
+        </p:spPr>
+      </p:sp>
+      <p:sp>
+        <p:nvSpPr>
+          <p:cNvPr id="28" name="Text 26"/>
+          <p:cNvSpPr txBox="1"/>
+          <p:nvPr/>
+        </p:nvSpPr>
+        <p:spPr>
+          <a:xfrm>
+            <a:off x="4754880" y="2688336"/>
+            <a:ext cx="292608" cy="292608"/>
+          </a:xfrm>
+          <a:prstGeom prst="rect">
+            <a:avLst/>
+          </a:prstGeom>
+          <a:noFill/>
+          <a:ln/>
+        </p:spPr>
+        <p:txBody>
+          <a:bodyPr wrap="square" lIns="0" tIns="0" rIns="0" bIns="0" rtlCol="0" anchor="ctr"/>
+          <a:lstStyle/>
+          <a:p>
+            <a:pPr algn="ctr" indent="0" marL="0">
+              <a:buNone/>
+            </a:pPr>
+            <a:r>
+              <a:rPr lang="en-US" sz="1400" b="1" dirty="0">
+                <a:solidFill>
+                  <a:srgbClr val="FFFFFF"/>
+                </a:solidFill>
+                <a:latin typeface="Calibri" pitchFamily="34" charset="0"/>
+                <a:ea typeface="Calibri" pitchFamily="34" charset="-122"/>
+                <a:cs typeface="Calibri" pitchFamily="34" charset="-120"/>
+              </a:rPr>
+              <a:t>7</a:t>
+            </a:r>
+            <a:endParaRPr lang="en-US" sz="1400" dirty="0"/>
+          </a:p>
+        </p:txBody>
+      </p:sp>
+      <p:sp>
+        <p:nvSpPr>
+          <p:cNvPr id="29" name="Text 27"/>
+          <p:cNvSpPr txBox="1"/>
+          <p:nvPr/>
+        </p:nvSpPr>
+        <p:spPr>
+          <a:xfrm>
+            <a:off x="5175504" y="2670048"/>
+            <a:ext cx="3566160" cy="274320"/>
+          </a:xfrm>
+          <a:prstGeom prst="rect">
+            <a:avLst/>
+          </a:prstGeom>
+          <a:noFill/>
+          <a:ln/>
+        </p:spPr>
+        <p:txBody>
+          <a:bodyPr wrap="square" lIns="0" tIns="0" rIns="0" bIns="0" rtlCol="0" anchor="ctr"/>
+          <a:lstStyle/>
+          <a:p>
+            <a:pPr indent="0" marL="0">
+              <a:buNone/>
+            </a:pPr>
+            <a:r>
+              <a:rPr lang="en-US" sz="1300" b="1" dirty="0">
+                <a:solidFill>
+                  <a:srgbClr val="1C1C1E"/>
+                </a:solidFill>
+                <a:latin typeface="Calibri" pitchFamily="34" charset="0"/>
+                <a:ea typeface="Calibri" pitchFamily="34" charset="-122"/>
+                <a:cs typeface="Calibri" pitchFamily="34" charset="-120"/>
+              </a:rPr>
+              <a:t>Competência ≠ mês do acidente</a:t>
+            </a:r>
+            <a:endParaRPr lang="en-US" sz="1300" dirty="0"/>
+          </a:p>
+        </p:txBody>
+      </p:sp>
+      <p:sp>
+        <p:nvSpPr>
+          <p:cNvPr id="30" name="Text 28"/>
+          <p:cNvSpPr txBox="1"/>
+          <p:nvPr/>
+        </p:nvSpPr>
+        <p:spPr>
+          <a:xfrm>
+            <a:off x="5175504" y="2935224"/>
+            <a:ext cx="3566160" cy="402336"/>
+          </a:xfrm>
+          <a:prstGeom prst="rect">
+            <a:avLst/>
+          </a:prstGeom>
+          <a:noFill/>
+          <a:ln/>
+        </p:spPr>
+        <p:txBody>
+          <a:bodyPr wrap="square" lIns="0" tIns="0" rIns="0" bIns="0" rtlCol="0" anchor="ctr"/>
+          <a:lstStyle/>
+          <a:p>
+            <a:pPr indent="0" marL="0">
+              <a:buNone/>
+            </a:pPr>
+            <a:r>
+              <a:rPr lang="en-US" sz="1150" dirty="0">
+                <a:solidFill>
+                  <a:srgbClr val="6B6A66"/>
+                </a:solidFill>
+                <a:latin typeface="Calibri" pitchFamily="34" charset="0"/>
+                <a:ea typeface="Calibri" pitchFamily="34" charset="-122"/>
+                <a:cs typeface="Calibri" pitchFamily="34" charset="-120"/>
+              </a:rPr>
+              <a:t>a série temporal por arquivo fica errada</a:t>
+            </a:r>
+            <a:endParaRPr lang="en-US" sz="1150" dirty="0"/>
+          </a:p>
+        </p:txBody>
+      </p:sp>
+      <p:sp>
+        <p:nvSpPr>
+          <p:cNvPr id="31" name="Text 29"/>
+          <p:cNvSpPr txBox="1"/>
+          <p:nvPr/>
+        </p:nvSpPr>
+        <p:spPr>
+          <a:xfrm>
+            <a:off x="502920" y="4279392"/>
             <a:ext cx="8138160" cy="548640"/>
           </a:xfrm>
           <a:prstGeom prst="rect">
@@ -4027,17 +5213,17 @@
               <a:buNone/>
             </a:pPr>
             <a:r>
-              <a:rPr lang="en-US" sz="1350" dirty="0">
-                <a:solidFill>
-                  <a:srgbClr val="1C1C1E"/>
-                </a:solidFill>
-                <a:latin typeface="Calibri" pitchFamily="34" charset="0"/>
-                <a:ea typeface="Calibri" pitchFamily="34" charset="-122"/>
-                <a:cs typeface="Calibri" pitchFamily="34" charset="-120"/>
-              </a:rPr>
-              <a:t>São Paulo estava gravado como “Maranhão”. E 12 UFs — RS, SC, BA entre elas — não têm rótulo algum: 33% da base. Decisão: usar a UF derivada do código IBGE.</a:t>
-            </a:r>
-            <a:endParaRPr lang="en-US" sz="1350" dirty="0"/>
+              <a:rPr lang="en-US" sz="1300" i="1" dirty="0">
+                <a:solidFill>
+                  <a:srgbClr val="EB6834"/>
+                </a:solidFill>
+                <a:latin typeface="Calibri" pitchFamily="34" charset="0"/>
+                <a:ea typeface="Calibri" pitchFamily="34" charset="-122"/>
+                <a:cs typeface="Calibri" pitchFamily="34" charset="-120"/>
+              </a:rPr>
+              <a:t>Nenhuma delas dá erro de execução. Todas dão resultado errado em silêncio — por isso a etapa de exploração levou mais tempo que a análise.</a:t>
+            </a:r>
+            <a:endParaRPr lang="en-US" sz="1300" dirty="0"/>
           </a:p>
         </p:txBody>
       </p:sp>
@@ -4099,7 +5285,7 @@
                 <a:ea typeface="Cambria" pitchFamily="34" charset="-122"/>
                 <a:cs typeface="Cambria" pitchFamily="34" charset="-120"/>
               </a:rPr>
-              <a:t>REFINE — os arquivos que se repetiam</a:t>
+              <a:t>REFINE — a coluna que mentia</a:t>
             </a:r>
             <a:endParaRPr lang="en-US" sz="3000" dirty="0"/>
           </a:p>
@@ -4107,7 +5293,7 @@
       </p:sp>
       <p:pic>
         <p:nvPicPr>
-          <p:cNvPr id="3" name="Image 0" descr="/home/user/ufpr-ppgcd-acidentes-no-trabalho/reports/apresentacao/figuras/republicacao.png">    </p:cNvPr>
+          <p:cNvPr id="3" name="Image 0" descr="/home/user/ufpr-ppgcd-acidentes-no-trabalho/reports/apresentacao/figuras/uf-trocada.png">    </p:cNvPr>
           <p:cNvPicPr>
             <a:picLocks noChangeAspect="1"/>
           </p:cNvPicPr>
@@ -4121,8 +5307,8 @@
         </p:blipFill>
         <p:spPr>
           <a:xfrm>
-            <a:off x="502920" y="1143000"/>
-            <a:ext cx="4663440" cy="2698750"/>
+            <a:off x="502920" y="1078992"/>
+            <a:ext cx="7863840" cy="3040928"/>
           </a:xfrm>
           <a:prstGeom prst="rect">
             <a:avLst/>
@@ -4137,266 +5323,32 @@
         </p:nvSpPr>
         <p:spPr>
           <a:xfrm>
-            <a:off x="5486400" y="1298448"/>
-            <a:ext cx="3200400" cy="411480"/>
-          </a:xfrm>
-          <a:prstGeom prst="rect">
-            <a:avLst/>
-          </a:prstGeom>
-          <a:noFill/>
-          <a:ln/>
-        </p:spPr>
-        <p:txBody>
-          <a:bodyPr wrap="square" lIns="0" tIns="0" rIns="0" bIns="0" rtlCol="0" anchor="ctr"/>
-          <a:lstStyle/>
-          <a:p>
-            <a:pPr indent="0" marL="0">
-              <a:buNone/>
-            </a:pPr>
-            <a:r>
-              <a:rPr lang="en-US" sz="2400" b="1" dirty="0">
-                <a:solidFill>
-                  <a:srgbClr val="EB6834"/>
-                </a:solidFill>
-                <a:latin typeface="Cambria" pitchFamily="34" charset="0"/>
-                <a:ea typeface="Cambria" pitchFamily="34" charset="-122"/>
-                <a:cs typeface="Cambria" pitchFamily="34" charset="-120"/>
-              </a:rPr>
-              <a:t>11,7%</a:t>
-            </a:r>
-            <a:endParaRPr lang="en-US" sz="2400" dirty="0"/>
-          </a:p>
-        </p:txBody>
-      </p:sp>
-      <p:sp>
-        <p:nvSpPr>
-          <p:cNvPr id="5" name="Text 2"/>
-          <p:cNvSpPr txBox="1"/>
-          <p:nvPr/>
-        </p:nvSpPr>
-        <p:spPr>
-          <a:xfrm>
-            <a:off x="5486400" y="1700784"/>
-            <a:ext cx="3200400" cy="457200"/>
-          </a:xfrm>
-          <a:prstGeom prst="rect">
-            <a:avLst/>
-          </a:prstGeom>
-          <a:noFill/>
-          <a:ln/>
-        </p:spPr>
-        <p:txBody>
-          <a:bodyPr wrap="square" lIns="0" tIns="0" rIns="0" bIns="0" rtlCol="0" anchor="ctr"/>
-          <a:lstStyle/>
-          <a:p>
-            <a:pPr indent="0" marL="0">
-              <a:buNone/>
-            </a:pPr>
-            <a:r>
-              <a:rPr lang="en-US" sz="1250" dirty="0">
-                <a:solidFill>
-                  <a:srgbClr val="6B6A66"/>
-                </a:solidFill>
-                <a:latin typeface="Calibri" pitchFamily="34" charset="0"/>
-                <a:ea typeface="Calibri" pitchFamily="34" charset="-122"/>
-                <a:cs typeface="Calibri" pitchFamily="34" charset="-120"/>
-              </a:rPr>
-              <a:t>das linhas já haviam sido publicadas</a:t>
-            </a:r>
-            <a:endParaRPr lang="en-US" sz="1250" dirty="0"/>
-          </a:p>
-        </p:txBody>
-      </p:sp>
-      <p:sp>
-        <p:nvSpPr>
-          <p:cNvPr id="6" name="Text 3"/>
-          <p:cNvSpPr txBox="1"/>
-          <p:nvPr/>
-        </p:nvSpPr>
-        <p:spPr>
-          <a:xfrm>
-            <a:off x="5486400" y="2267712"/>
-            <a:ext cx="3200400" cy="411480"/>
-          </a:xfrm>
-          <a:prstGeom prst="rect">
-            <a:avLst/>
-          </a:prstGeom>
-          <a:noFill/>
-          <a:ln/>
-        </p:spPr>
-        <p:txBody>
-          <a:bodyPr wrap="square" lIns="0" tIns="0" rIns="0" bIns="0" rtlCol="0" anchor="ctr"/>
-          <a:lstStyle/>
-          <a:p>
-            <a:pPr indent="0" marL="0">
-              <a:buNone/>
-            </a:pPr>
-            <a:r>
-              <a:rPr lang="en-US" sz="2400" b="1" dirty="0">
-                <a:solidFill>
-                  <a:srgbClr val="EB6834"/>
-                </a:solidFill>
-                <a:latin typeface="Cambria" pitchFamily="34" charset="0"/>
-                <a:ea typeface="Cambria" pitchFamily="34" charset="-122"/>
-                <a:cs typeface="Cambria" pitchFamily="34" charset="-120"/>
-              </a:rPr>
-              <a:t>8 arquivos</a:t>
-            </a:r>
-            <a:endParaRPr lang="en-US" sz="2400" dirty="0"/>
-          </a:p>
-        </p:txBody>
-      </p:sp>
-      <p:sp>
-        <p:nvSpPr>
-          <p:cNvPr id="7" name="Text 4"/>
-          <p:cNvSpPr txBox="1"/>
-          <p:nvPr/>
-        </p:nvSpPr>
-        <p:spPr>
-          <a:xfrm>
-            <a:off x="5486400" y="2670048"/>
-            <a:ext cx="3200400" cy="457200"/>
-          </a:xfrm>
-          <a:prstGeom prst="rect">
-            <a:avLst/>
-          </a:prstGeom>
-          <a:noFill/>
-          <a:ln/>
-        </p:spPr>
-        <p:txBody>
-          <a:bodyPr wrap="square" lIns="0" tIns="0" rIns="0" bIns="0" rtlCol="0" anchor="ctr"/>
-          <a:lstStyle/>
-          <a:p>
-            <a:pPr indent="0" marL="0">
-              <a:buNone/>
-            </a:pPr>
-            <a:r>
-              <a:rPr lang="en-US" sz="1250" dirty="0">
-                <a:solidFill>
-                  <a:srgbClr val="6B6A66"/>
-                </a:solidFill>
-                <a:latin typeface="Calibri" pitchFamily="34" charset="0"/>
-                <a:ea typeface="Calibri" pitchFamily="34" charset="-122"/>
-                <a:cs typeface="Calibri" pitchFamily="34" charset="-120"/>
-              </a:rPr>
-              <a:t>sem um único registro novo</a:t>
-            </a:r>
-            <a:endParaRPr lang="en-US" sz="1250" dirty="0"/>
-          </a:p>
-        </p:txBody>
-      </p:sp>
-      <p:sp>
-        <p:nvSpPr>
-          <p:cNvPr id="8" name="Text 5"/>
-          <p:cNvSpPr txBox="1"/>
-          <p:nvPr/>
-        </p:nvSpPr>
-        <p:spPr>
-          <a:xfrm>
-            <a:off x="5486400" y="3236976"/>
-            <a:ext cx="3200400" cy="411480"/>
-          </a:xfrm>
-          <a:prstGeom prst="rect">
-            <a:avLst/>
-          </a:prstGeom>
-          <a:noFill/>
-          <a:ln/>
-        </p:spPr>
-        <p:txBody>
-          <a:bodyPr wrap="square" lIns="0" tIns="0" rIns="0" bIns="0" rtlCol="0" anchor="ctr"/>
-          <a:lstStyle/>
-          <a:p>
-            <a:pPr indent="0" marL="0">
-              <a:buNone/>
-            </a:pPr>
-            <a:r>
-              <a:rPr lang="en-US" sz="2400" b="1" dirty="0">
-                <a:solidFill>
-                  <a:srgbClr val="EB6834"/>
-                </a:solidFill>
-                <a:latin typeface="Cambria" pitchFamily="34" charset="0"/>
-                <a:ea typeface="Cambria" pitchFamily="34" charset="-122"/>
-                <a:cs typeface="Cambria" pitchFamily="34" charset="-120"/>
-              </a:rPr>
-              <a:t>458 mil</a:t>
-            </a:r>
-            <a:endParaRPr lang="en-US" sz="2400" dirty="0"/>
-          </a:p>
-        </p:txBody>
-      </p:sp>
-      <p:sp>
-        <p:nvSpPr>
-          <p:cNvPr id="9" name="Text 6"/>
-          <p:cNvSpPr txBox="1"/>
-          <p:nvPr/>
-        </p:nvSpPr>
-        <p:spPr>
-          <a:xfrm>
-            <a:off x="5486400" y="3639312"/>
-            <a:ext cx="3200400" cy="457200"/>
-          </a:xfrm>
-          <a:prstGeom prst="rect">
-            <a:avLst/>
-          </a:prstGeom>
-          <a:noFill/>
-          <a:ln/>
-        </p:spPr>
-        <p:txBody>
-          <a:bodyPr wrap="square" lIns="0" tIns="0" rIns="0" bIns="0" rtlCol="0" anchor="ctr"/>
-          <a:lstStyle/>
-          <a:p>
-            <a:pPr indent="0" marL="0">
-              <a:buNone/>
-            </a:pPr>
-            <a:r>
-              <a:rPr lang="en-US" sz="1250" dirty="0">
-                <a:solidFill>
-                  <a:srgbClr val="6B6A66"/>
-                </a:solidFill>
-                <a:latin typeface="Calibri" pitchFamily="34" charset="0"/>
-                <a:ea typeface="Calibri" pitchFamily="34" charset="-122"/>
-                <a:cs typeface="Calibri" pitchFamily="34" charset="-120"/>
-              </a:rPr>
-              <a:t>de diferença na contagem</a:t>
-            </a:r>
-            <a:endParaRPr lang="en-US" sz="1250" dirty="0"/>
-          </a:p>
-        </p:txBody>
-      </p:sp>
-      <p:sp>
-        <p:nvSpPr>
-          <p:cNvPr id="10" name="Text 7"/>
-          <p:cNvSpPr txBox="1"/>
-          <p:nvPr/>
-        </p:nvSpPr>
-        <p:spPr>
-          <a:xfrm>
-            <a:off x="502920" y="4315968"/>
-            <a:ext cx="8138160" cy="411480"/>
-          </a:xfrm>
-          <a:prstGeom prst="rect">
-            <a:avLst/>
-          </a:prstGeom>
-          <a:noFill/>
-          <a:ln/>
-        </p:spPr>
-        <p:txBody>
-          <a:bodyPr wrap="square" lIns="0" tIns="0" rIns="0" bIns="0" rtlCol="0" anchor="ctr"/>
-          <a:lstStyle/>
-          <a:p>
-            <a:pPr indent="0" marL="0">
-              <a:buNone/>
-            </a:pPr>
-            <a:r>
-              <a:rPr lang="en-US" sz="1350" i="1" dirty="0">
-                <a:solidFill>
-                  <a:srgbClr val="EB6834"/>
-                </a:solidFill>
-                <a:latin typeface="Calibri" pitchFamily="34" charset="0"/>
-                <a:ea typeface="Calibri" pitchFamily="34" charset="-122"/>
-                <a:cs typeface="Calibri" pitchFamily="34" charset="-120"/>
-              </a:rPr>
-              <a:t>Marcamos em vez de apagar: a base guarda o problema e a decisão fica auditável.</a:t>
+            <a:off x="502920" y="4261104"/>
+            <a:ext cx="8138160" cy="548640"/>
+          </a:xfrm>
+          <a:prstGeom prst="rect">
+            <a:avLst/>
+          </a:prstGeom>
+          <a:noFill/>
+          <a:ln/>
+        </p:spPr>
+        <p:txBody>
+          <a:bodyPr wrap="square" lIns="0" tIns="0" rIns="0" bIns="0" rtlCol="0" anchor="ctr"/>
+          <a:lstStyle/>
+          <a:p>
+            <a:pPr indent="0" marL="0">
+              <a:buNone/>
+            </a:pPr>
+            <a:r>
+              <a:rPr lang="en-US" sz="1350" dirty="0">
+                <a:solidFill>
+                  <a:srgbClr val="1C1C1E"/>
+                </a:solidFill>
+                <a:latin typeface="Calibri" pitchFamily="34" charset="0"/>
+                <a:ea typeface="Calibri" pitchFamily="34" charset="-122"/>
+                <a:cs typeface="Calibri" pitchFamily="34" charset="-120"/>
+              </a:rPr>
+              <a:t>São Paulo estava gravado como “Maranhão”. E 12 UFs — RS, SC, BA entre elas — não têm rótulo algum: 33% da base. Decisão: usar a UF derivada do código IBGE.</a:t>
             </a:r>
             <a:endParaRPr lang="en-US" sz="1350" dirty="0"/>
           </a:p>
@@ -4460,125 +5412,85 @@
                 <a:ea typeface="Cambria" pitchFamily="34" charset="-122"/>
                 <a:cs typeface="Cambria" pitchFamily="34" charset="-120"/>
               </a:rPr>
-              <a:t>PRODUCE — o que foi produzido</a:t>
+              <a:t>REFINE — os arquivos que se repetiam</a:t>
             </a:r>
             <a:endParaRPr lang="en-US" sz="3000" dirty="0"/>
           </a:p>
         </p:txBody>
       </p:sp>
-      <p:sp>
-        <p:nvSpPr>
-          <p:cNvPr id="3" name="Shape 1"/>
-          <p:cNvSpPr/>
-          <p:nvPr/>
-        </p:nvSpPr>
-        <p:spPr>
-          <a:xfrm>
-            <a:off x="502920" y="1207008"/>
-            <a:ext cx="310896" cy="310896"/>
-          </a:xfrm>
-          <a:prstGeom prst="ellipse">
-            <a:avLst/>
-          </a:prstGeom>
-          <a:solidFill>
-            <a:srgbClr val="EB6834"/>
-          </a:solidFill>
-          <a:ln w="12700">
-            <a:solidFill>
-              <a:srgbClr val="EB6834"/>
-            </a:solidFill>
-            <a:prstDash val="solid"/>
-          </a:ln>
-        </p:spPr>
-      </p:sp>
-      <p:sp>
-        <p:nvSpPr>
-          <p:cNvPr id="4" name="Text 2"/>
-          <p:cNvSpPr txBox="1"/>
-          <p:nvPr/>
-        </p:nvSpPr>
-        <p:spPr>
-          <a:xfrm>
-            <a:off x="502920" y="1207008"/>
-            <a:ext cx="310896" cy="310896"/>
-          </a:xfrm>
-          <a:prstGeom prst="rect">
-            <a:avLst/>
-          </a:prstGeom>
-          <a:noFill/>
-          <a:ln/>
-        </p:spPr>
-        <p:txBody>
-          <a:bodyPr wrap="square" lIns="0" tIns="0" rIns="0" bIns="0" rtlCol="0" anchor="ctr"/>
-          <a:lstStyle/>
-          <a:p>
-            <a:pPr algn="ctr" indent="0" marL="0">
-              <a:buNone/>
-            </a:pPr>
-            <a:r>
-              <a:rPr lang="en-US" sz="1500" b="1" dirty="0">
-                <a:solidFill>
-                  <a:srgbClr val="FFFFFF"/>
-                </a:solidFill>
-                <a:latin typeface="Calibri" pitchFamily="34" charset="0"/>
-                <a:ea typeface="Calibri" pitchFamily="34" charset="-122"/>
-                <a:cs typeface="Calibri" pitchFamily="34" charset="-120"/>
-              </a:rPr>
-              <a:t>1</a:t>
-            </a:r>
-            <a:endParaRPr lang="en-US" sz="1500" dirty="0"/>
-          </a:p>
-        </p:txBody>
-      </p:sp>
-      <p:sp>
-        <p:nvSpPr>
-          <p:cNvPr id="5" name="Text 3"/>
-          <p:cNvSpPr txBox="1"/>
-          <p:nvPr/>
-        </p:nvSpPr>
-        <p:spPr>
-          <a:xfrm>
-            <a:off x="960120" y="1188720"/>
-            <a:ext cx="2651760" cy="292608"/>
-          </a:xfrm>
-          <a:prstGeom prst="rect">
-            <a:avLst/>
-          </a:prstGeom>
-          <a:noFill/>
-          <a:ln/>
-        </p:spPr>
-        <p:txBody>
-          <a:bodyPr wrap="square" lIns="0" tIns="0" rIns="0" bIns="0" rtlCol="0" anchor="ctr"/>
-          <a:lstStyle/>
-          <a:p>
-            <a:pPr indent="0" marL="0">
-              <a:buNone/>
-            </a:pPr>
-            <a:r>
-              <a:rPr lang="en-US" sz="1400" b="1" dirty="0">
-                <a:solidFill>
-                  <a:srgbClr val="1C1C1E"/>
-                </a:solidFill>
-                <a:latin typeface="Calibri" pitchFamily="34" charset="0"/>
-                <a:ea typeface="Calibri" pitchFamily="34" charset="-122"/>
-                <a:cs typeface="Calibri" pitchFamily="34" charset="-120"/>
-              </a:rPr>
-              <a:t>Base única</a:t>
-            </a:r>
-            <a:endParaRPr lang="en-US" sz="1400" dirty="0"/>
-          </a:p>
-        </p:txBody>
-      </p:sp>
-      <p:sp>
-        <p:nvSpPr>
-          <p:cNvPr id="6" name="Text 4"/>
-          <p:cNvSpPr txBox="1"/>
-          <p:nvPr/>
-        </p:nvSpPr>
-        <p:spPr>
-          <a:xfrm>
-            <a:off x="3657600" y="1207008"/>
-            <a:ext cx="4983480" cy="548640"/>
+      <p:pic>
+        <p:nvPicPr>
+          <p:cNvPr id="3" name="Image 0" descr="/home/user/ufpr-ppgcd-acidentes-no-trabalho/reports/apresentacao/figuras/republicacao.png">    </p:cNvPr>
+          <p:cNvPicPr>
+            <a:picLocks noChangeAspect="1"/>
+          </p:cNvPicPr>
+          <p:nvPr/>
+        </p:nvPicPr>
+        <p:blipFill>
+          <a:blip r:embed="rId1"/>
+          <a:stretch>
+            <a:fillRect/>
+          </a:stretch>
+        </p:blipFill>
+        <p:spPr>
+          <a:xfrm>
+            <a:off x="502920" y="1143000"/>
+            <a:ext cx="4663440" cy="2698750"/>
+          </a:xfrm>
+          <a:prstGeom prst="rect">
+            <a:avLst/>
+          </a:prstGeom>
+        </p:spPr>
+      </p:pic>
+      <p:sp>
+        <p:nvSpPr>
+          <p:cNvPr id="4" name="Text 1"/>
+          <p:cNvSpPr txBox="1"/>
+          <p:nvPr/>
+        </p:nvSpPr>
+        <p:spPr>
+          <a:xfrm>
+            <a:off x="5486400" y="1298448"/>
+            <a:ext cx="3200400" cy="411480"/>
+          </a:xfrm>
+          <a:prstGeom prst="rect">
+            <a:avLst/>
+          </a:prstGeom>
+          <a:noFill/>
+          <a:ln/>
+        </p:spPr>
+        <p:txBody>
+          <a:bodyPr wrap="square" lIns="0" tIns="0" rIns="0" bIns="0" rtlCol="0" anchor="ctr"/>
+          <a:lstStyle/>
+          <a:p>
+            <a:pPr indent="0" marL="0">
+              <a:buNone/>
+            </a:pPr>
+            <a:r>
+              <a:rPr lang="en-US" sz="2400" b="1" dirty="0">
+                <a:solidFill>
+                  <a:srgbClr val="EB6834"/>
+                </a:solidFill>
+                <a:latin typeface="Cambria" pitchFamily="34" charset="0"/>
+                <a:ea typeface="Cambria" pitchFamily="34" charset="-122"/>
+                <a:cs typeface="Cambria" pitchFamily="34" charset="-120"/>
+              </a:rPr>
+              <a:t>11,7%</a:t>
+            </a:r>
+            <a:endParaRPr lang="en-US" sz="2400" dirty="0"/>
+          </a:p>
+        </p:txBody>
+      </p:sp>
+      <p:sp>
+        <p:nvSpPr>
+          <p:cNvPr id="5" name="Text 2"/>
+          <p:cNvSpPr txBox="1"/>
+          <p:nvPr/>
+        </p:nvSpPr>
+        <p:spPr>
+          <a:xfrm>
+            <a:off x="5486400" y="1700784"/>
+            <a:ext cx="3200400" cy="457200"/>
           </a:xfrm>
           <a:prstGeom prst="rect">
             <a:avLst/>
@@ -4602,7 +5514,7 @@
                 <a:ea typeface="Calibri" pitchFamily="34" charset="-122"/>
                 <a:cs typeface="Calibri" pitchFamily="34" charset="-120"/>
               </a:rPr>
-              <a:t>3,47 milhões de registros · 1,8 GB de CSV → 94 MB de Parquet</a:t>
+              <a:t>das linhas já haviam sido publicadas</a:t>
             </a:r>
             <a:endParaRPr lang="en-US" sz="1250" dirty="0"/>
           </a:p>
@@ -4610,117 +5522,53 @@
       </p:sp>
       <p:sp>
         <p:nvSpPr>
-          <p:cNvPr id="7" name="Shape 5"/>
-          <p:cNvSpPr/>
-          <p:nvPr/>
-        </p:nvSpPr>
-        <p:spPr>
-          <a:xfrm>
-            <a:off x="502920" y="1956816"/>
-            <a:ext cx="310896" cy="310896"/>
-          </a:xfrm>
-          <a:prstGeom prst="ellipse">
-            <a:avLst/>
-          </a:prstGeom>
-          <a:solidFill>
-            <a:srgbClr val="EB6834"/>
-          </a:solidFill>
-          <a:ln w="12700">
-            <a:solidFill>
-              <a:srgbClr val="EB6834"/>
-            </a:solidFill>
-            <a:prstDash val="solid"/>
-          </a:ln>
-        </p:spPr>
-      </p:sp>
-      <p:sp>
-        <p:nvSpPr>
-          <p:cNvPr id="8" name="Text 6"/>
-          <p:cNvSpPr txBox="1"/>
-          <p:nvPr/>
-        </p:nvSpPr>
-        <p:spPr>
-          <a:xfrm>
-            <a:off x="502920" y="1956816"/>
-            <a:ext cx="310896" cy="310896"/>
-          </a:xfrm>
-          <a:prstGeom prst="rect">
-            <a:avLst/>
-          </a:prstGeom>
-          <a:noFill/>
-          <a:ln/>
-        </p:spPr>
-        <p:txBody>
-          <a:bodyPr wrap="square" lIns="0" tIns="0" rIns="0" bIns="0" rtlCol="0" anchor="ctr"/>
-          <a:lstStyle/>
-          <a:p>
-            <a:pPr algn="ctr" indent="0" marL="0">
-              <a:buNone/>
-            </a:pPr>
-            <a:r>
-              <a:rPr lang="en-US" sz="1500" b="1" dirty="0">
-                <a:solidFill>
-                  <a:srgbClr val="FFFFFF"/>
-                </a:solidFill>
-                <a:latin typeface="Calibri" pitchFamily="34" charset="0"/>
-                <a:ea typeface="Calibri" pitchFamily="34" charset="-122"/>
-                <a:cs typeface="Calibri" pitchFamily="34" charset="-120"/>
-              </a:rPr>
-              <a:t>2</a:t>
-            </a:r>
-            <a:endParaRPr lang="en-US" sz="1500" dirty="0"/>
-          </a:p>
-        </p:txBody>
-      </p:sp>
-      <p:sp>
-        <p:nvSpPr>
-          <p:cNvPr id="9" name="Text 7"/>
-          <p:cNvSpPr txBox="1"/>
-          <p:nvPr/>
-        </p:nvSpPr>
-        <p:spPr>
-          <a:xfrm>
-            <a:off x="960120" y="1938528"/>
-            <a:ext cx="2651760" cy="292608"/>
-          </a:xfrm>
-          <a:prstGeom prst="rect">
-            <a:avLst/>
-          </a:prstGeom>
-          <a:noFill/>
-          <a:ln/>
-        </p:spPr>
-        <p:txBody>
-          <a:bodyPr wrap="square" lIns="0" tIns="0" rIns="0" bIns="0" rtlCol="0" anchor="ctr"/>
-          <a:lstStyle/>
-          <a:p>
-            <a:pPr indent="0" marL="0">
-              <a:buNone/>
-            </a:pPr>
-            <a:r>
-              <a:rPr lang="en-US" sz="1400" b="1" dirty="0">
-                <a:solidFill>
-                  <a:srgbClr val="1C1C1E"/>
-                </a:solidFill>
-                <a:latin typeface="Calibri" pitchFamily="34" charset="0"/>
-                <a:ea typeface="Calibri" pitchFamily="34" charset="-122"/>
-                <a:cs typeface="Calibri" pitchFamily="34" charset="-120"/>
-              </a:rPr>
-              <a:t>Pipeline reproduzível</a:t>
-            </a:r>
-            <a:endParaRPr lang="en-US" sz="1400" dirty="0"/>
-          </a:p>
-        </p:txBody>
-      </p:sp>
-      <p:sp>
-        <p:nvSpPr>
-          <p:cNvPr id="10" name="Text 8"/>
-          <p:cNvSpPr txBox="1"/>
-          <p:nvPr/>
-        </p:nvSpPr>
-        <p:spPr>
-          <a:xfrm>
-            <a:off x="3657600" y="1956816"/>
-            <a:ext cx="4983480" cy="548640"/>
+          <p:cNvPr id="6" name="Text 3"/>
+          <p:cNvSpPr txBox="1"/>
+          <p:nvPr/>
+        </p:nvSpPr>
+        <p:spPr>
+          <a:xfrm>
+            <a:off x="5486400" y="2267712"/>
+            <a:ext cx="3200400" cy="411480"/>
+          </a:xfrm>
+          <a:prstGeom prst="rect">
+            <a:avLst/>
+          </a:prstGeom>
+          <a:noFill/>
+          <a:ln/>
+        </p:spPr>
+        <p:txBody>
+          <a:bodyPr wrap="square" lIns="0" tIns="0" rIns="0" bIns="0" rtlCol="0" anchor="ctr"/>
+          <a:lstStyle/>
+          <a:p>
+            <a:pPr indent="0" marL="0">
+              <a:buNone/>
+            </a:pPr>
+            <a:r>
+              <a:rPr lang="en-US" sz="2400" b="1" dirty="0">
+                <a:solidFill>
+                  <a:srgbClr val="EB6834"/>
+                </a:solidFill>
+                <a:latin typeface="Cambria" pitchFamily="34" charset="0"/>
+                <a:ea typeface="Cambria" pitchFamily="34" charset="-122"/>
+                <a:cs typeface="Cambria" pitchFamily="34" charset="-120"/>
+              </a:rPr>
+              <a:t>8 arquivos</a:t>
+            </a:r>
+            <a:endParaRPr lang="en-US" sz="2400" dirty="0"/>
+          </a:p>
+        </p:txBody>
+      </p:sp>
+      <p:sp>
+        <p:nvSpPr>
+          <p:cNvPr id="7" name="Text 4"/>
+          <p:cNvSpPr txBox="1"/>
+          <p:nvPr/>
+        </p:nvSpPr>
+        <p:spPr>
+          <a:xfrm>
+            <a:off x="5486400" y="2670048"/>
+            <a:ext cx="3200400" cy="457200"/>
           </a:xfrm>
           <a:prstGeom prst="rect">
             <a:avLst/>
@@ -4744,7 +5592,7 @@
                 <a:ea typeface="Calibri" pitchFamily="34" charset="-122"/>
                 <a:cs typeface="Calibri" pitchFamily="34" charset="-120"/>
               </a:rPr>
-              <a:t>quatro etapas retomáveis · reconstrói tudo em 2 minutos</a:t>
+              <a:t>sem um único registro novo</a:t>
             </a:r>
             <a:endParaRPr lang="en-US" sz="1250" dirty="0"/>
           </a:p>
@@ -4752,117 +5600,53 @@
       </p:sp>
       <p:sp>
         <p:nvSpPr>
-          <p:cNvPr id="11" name="Shape 9"/>
-          <p:cNvSpPr/>
-          <p:nvPr/>
-        </p:nvSpPr>
-        <p:spPr>
-          <a:xfrm>
-            <a:off x="502920" y="2706624"/>
-            <a:ext cx="310896" cy="310896"/>
-          </a:xfrm>
-          <a:prstGeom prst="ellipse">
-            <a:avLst/>
-          </a:prstGeom>
-          <a:solidFill>
-            <a:srgbClr val="EB6834"/>
-          </a:solidFill>
-          <a:ln w="12700">
-            <a:solidFill>
-              <a:srgbClr val="EB6834"/>
-            </a:solidFill>
-            <a:prstDash val="solid"/>
-          </a:ln>
-        </p:spPr>
-      </p:sp>
-      <p:sp>
-        <p:nvSpPr>
-          <p:cNvPr id="12" name="Text 10"/>
-          <p:cNvSpPr txBox="1"/>
-          <p:nvPr/>
-        </p:nvSpPr>
-        <p:spPr>
-          <a:xfrm>
-            <a:off x="502920" y="2706624"/>
-            <a:ext cx="310896" cy="310896"/>
-          </a:xfrm>
-          <a:prstGeom prst="rect">
-            <a:avLst/>
-          </a:prstGeom>
-          <a:noFill/>
-          <a:ln/>
-        </p:spPr>
-        <p:txBody>
-          <a:bodyPr wrap="square" lIns="0" tIns="0" rIns="0" bIns="0" rtlCol="0" anchor="ctr"/>
-          <a:lstStyle/>
-          <a:p>
-            <a:pPr algn="ctr" indent="0" marL="0">
-              <a:buNone/>
-            </a:pPr>
-            <a:r>
-              <a:rPr lang="en-US" sz="1500" b="1" dirty="0">
-                <a:solidFill>
-                  <a:srgbClr val="FFFFFF"/>
-                </a:solidFill>
-                <a:latin typeface="Calibri" pitchFamily="34" charset="0"/>
-                <a:ea typeface="Calibri" pitchFamily="34" charset="-122"/>
-                <a:cs typeface="Calibri" pitchFamily="34" charset="-120"/>
-              </a:rPr>
-              <a:t>3</a:t>
-            </a:r>
-            <a:endParaRPr lang="en-US" sz="1500" dirty="0"/>
-          </a:p>
-        </p:txBody>
-      </p:sp>
-      <p:sp>
-        <p:nvSpPr>
-          <p:cNvPr id="13" name="Text 11"/>
-          <p:cNvSpPr txBox="1"/>
-          <p:nvPr/>
-        </p:nvSpPr>
-        <p:spPr>
-          <a:xfrm>
-            <a:off x="960120" y="2688336"/>
-            <a:ext cx="2651760" cy="292608"/>
-          </a:xfrm>
-          <a:prstGeom prst="rect">
-            <a:avLst/>
-          </a:prstGeom>
-          <a:noFill/>
-          <a:ln/>
-        </p:spPr>
-        <p:txBody>
-          <a:bodyPr wrap="square" lIns="0" tIns="0" rIns="0" bIns="0" rtlCol="0" anchor="ctr"/>
-          <a:lstStyle/>
-          <a:p>
-            <a:pPr indent="0" marL="0">
-              <a:buNone/>
-            </a:pPr>
-            <a:r>
-              <a:rPr lang="en-US" sz="1400" b="1" dirty="0">
-                <a:solidFill>
-                  <a:srgbClr val="1C1C1E"/>
-                </a:solidFill>
-                <a:latin typeface="Calibri" pitchFamily="34" charset="0"/>
-                <a:ea typeface="Calibri" pitchFamily="34" charset="-122"/>
-                <a:cs typeface="Calibri" pitchFamily="34" charset="-120"/>
-              </a:rPr>
-              <a:t>Relatório automatizado</a:t>
-            </a:r>
-            <a:endParaRPr lang="en-US" sz="1400" dirty="0"/>
-          </a:p>
-        </p:txBody>
-      </p:sp>
-      <p:sp>
-        <p:nvSpPr>
-          <p:cNvPr id="14" name="Text 12"/>
-          <p:cNvSpPr txBox="1"/>
-          <p:nvPr/>
-        </p:nvSpPr>
-        <p:spPr>
-          <a:xfrm>
-            <a:off x="3657600" y="2706624"/>
-            <a:ext cx="4983480" cy="548640"/>
+          <p:cNvPr id="8" name="Text 5"/>
+          <p:cNvSpPr txBox="1"/>
+          <p:nvPr/>
+        </p:nvSpPr>
+        <p:spPr>
+          <a:xfrm>
+            <a:off x="5486400" y="3236976"/>
+            <a:ext cx="3200400" cy="411480"/>
+          </a:xfrm>
+          <a:prstGeom prst="rect">
+            <a:avLst/>
+          </a:prstGeom>
+          <a:noFill/>
+          <a:ln/>
+        </p:spPr>
+        <p:txBody>
+          <a:bodyPr wrap="square" lIns="0" tIns="0" rIns="0" bIns="0" rtlCol="0" anchor="ctr"/>
+          <a:lstStyle/>
+          <a:p>
+            <a:pPr indent="0" marL="0">
+              <a:buNone/>
+            </a:pPr>
+            <a:r>
+              <a:rPr lang="en-US" sz="2400" b="1" dirty="0">
+                <a:solidFill>
+                  <a:srgbClr val="EB6834"/>
+                </a:solidFill>
+                <a:latin typeface="Cambria" pitchFamily="34" charset="0"/>
+                <a:ea typeface="Cambria" pitchFamily="34" charset="-122"/>
+                <a:cs typeface="Cambria" pitchFamily="34" charset="-120"/>
+              </a:rPr>
+              <a:t>458 mil</a:t>
+            </a:r>
+            <a:endParaRPr lang="en-US" sz="2400" dirty="0"/>
+          </a:p>
+        </p:txBody>
+      </p:sp>
+      <p:sp>
+        <p:nvSpPr>
+          <p:cNvPr id="9" name="Text 6"/>
+          <p:cNvSpPr txBox="1"/>
+          <p:nvPr/>
+        </p:nvSpPr>
+        <p:spPr>
+          <a:xfrm>
+            <a:off x="5486400" y="3639312"/>
+            <a:ext cx="3200400" cy="457200"/>
           </a:xfrm>
           <a:prstGeom prst="rect">
             <a:avLst/>
@@ -4886,7 +5670,7 @@
                 <a:ea typeface="Calibri" pitchFamily="34" charset="-122"/>
                 <a:cs typeface="Calibri" pitchFamily="34" charset="-120"/>
               </a:rPr>
-              <a:t>volume, cobertura, domínios e consistência, regerado por comando</a:t>
+              <a:t>de diferença na contagem</a:t>
             </a:r>
             <a:endParaRPr lang="en-US" sz="1250" dirty="0"/>
           </a:p>
@@ -4894,149 +5678,7 @@
       </p:sp>
       <p:sp>
         <p:nvSpPr>
-          <p:cNvPr id="15" name="Shape 13"/>
-          <p:cNvSpPr/>
-          <p:nvPr/>
-        </p:nvSpPr>
-        <p:spPr>
-          <a:xfrm>
-            <a:off x="502920" y="3456432"/>
-            <a:ext cx="310896" cy="310896"/>
-          </a:xfrm>
-          <a:prstGeom prst="ellipse">
-            <a:avLst/>
-          </a:prstGeom>
-          <a:solidFill>
-            <a:srgbClr val="EB6834"/>
-          </a:solidFill>
-          <a:ln w="12700">
-            <a:solidFill>
-              <a:srgbClr val="EB6834"/>
-            </a:solidFill>
-            <a:prstDash val="solid"/>
-          </a:ln>
-        </p:spPr>
-      </p:sp>
-      <p:sp>
-        <p:nvSpPr>
-          <p:cNvPr id="16" name="Text 14"/>
-          <p:cNvSpPr txBox="1"/>
-          <p:nvPr/>
-        </p:nvSpPr>
-        <p:spPr>
-          <a:xfrm>
-            <a:off x="502920" y="3456432"/>
-            <a:ext cx="310896" cy="310896"/>
-          </a:xfrm>
-          <a:prstGeom prst="rect">
-            <a:avLst/>
-          </a:prstGeom>
-          <a:noFill/>
-          <a:ln/>
-        </p:spPr>
-        <p:txBody>
-          <a:bodyPr wrap="square" lIns="0" tIns="0" rIns="0" bIns="0" rtlCol="0" anchor="ctr"/>
-          <a:lstStyle/>
-          <a:p>
-            <a:pPr algn="ctr" indent="0" marL="0">
-              <a:buNone/>
-            </a:pPr>
-            <a:r>
-              <a:rPr lang="en-US" sz="1500" b="1" dirty="0">
-                <a:solidFill>
-                  <a:srgbClr val="FFFFFF"/>
-                </a:solidFill>
-                <a:latin typeface="Calibri" pitchFamily="34" charset="0"/>
-                <a:ea typeface="Calibri" pitchFamily="34" charset="-122"/>
-                <a:cs typeface="Calibri" pitchFamily="34" charset="-120"/>
-              </a:rPr>
-              <a:t>4</a:t>
-            </a:r>
-            <a:endParaRPr lang="en-US" sz="1500" dirty="0"/>
-          </a:p>
-        </p:txBody>
-      </p:sp>
-      <p:sp>
-        <p:nvSpPr>
-          <p:cNvPr id="17" name="Text 15"/>
-          <p:cNvSpPr txBox="1"/>
-          <p:nvPr/>
-        </p:nvSpPr>
-        <p:spPr>
-          <a:xfrm>
-            <a:off x="960120" y="3438144"/>
-            <a:ext cx="2651760" cy="292608"/>
-          </a:xfrm>
-          <a:prstGeom prst="rect">
-            <a:avLst/>
-          </a:prstGeom>
-          <a:noFill/>
-          <a:ln/>
-        </p:spPr>
-        <p:txBody>
-          <a:bodyPr wrap="square" lIns="0" tIns="0" rIns="0" bIns="0" rtlCol="0" anchor="ctr"/>
-          <a:lstStyle/>
-          <a:p>
-            <a:pPr indent="0" marL="0">
-              <a:buNone/>
-            </a:pPr>
-            <a:r>
-              <a:rPr lang="en-US" sz="1400" b="1" dirty="0">
-                <a:solidFill>
-                  <a:srgbClr val="1C1C1E"/>
-                </a:solidFill>
-                <a:latin typeface="Calibri" pitchFamily="34" charset="0"/>
-                <a:ea typeface="Calibri" pitchFamily="34" charset="-122"/>
-                <a:cs typeface="Calibri" pitchFamily="34" charset="-120"/>
-              </a:rPr>
-              <a:t>Notebook no Colab</a:t>
-            </a:r>
-            <a:endParaRPr lang="en-US" sz="1400" dirty="0"/>
-          </a:p>
-        </p:txBody>
-      </p:sp>
-      <p:sp>
-        <p:nvSpPr>
-          <p:cNvPr id="18" name="Text 16"/>
-          <p:cNvSpPr txBox="1"/>
-          <p:nvPr/>
-        </p:nvSpPr>
-        <p:spPr>
-          <a:xfrm>
-            <a:off x="3657600" y="3456432"/>
-            <a:ext cx="4983480" cy="548640"/>
-          </a:xfrm>
-          <a:prstGeom prst="rect">
-            <a:avLst/>
-          </a:prstGeom>
-          <a:noFill/>
-          <a:ln/>
-        </p:spPr>
-        <p:txBody>
-          <a:bodyPr wrap="square" lIns="0" tIns="0" rIns="0" bIns="0" rtlCol="0" anchor="ctr"/>
-          <a:lstStyle/>
-          <a:p>
-            <a:pPr indent="0" marL="0">
-              <a:buNone/>
-            </a:pPr>
-            <a:r>
-              <a:rPr lang="en-US" sz="1250" dirty="0">
-                <a:solidFill>
-                  <a:srgbClr val="6B6A66"/>
-                </a:solidFill>
-                <a:latin typeface="Calibri" pitchFamily="34" charset="0"/>
-                <a:ea typeface="Calibri" pitchFamily="34" charset="-122"/>
-                <a:cs typeface="Calibri" pitchFamily="34" charset="-120"/>
-              </a:rPr>
-              <a:t>a consolidação explicada passo a passo, executável por qualquer um</a:t>
-            </a:r>
-            <a:endParaRPr lang="en-US" sz="1250" dirty="0"/>
-          </a:p>
-        </p:txBody>
-      </p:sp>
-      <p:sp>
-        <p:nvSpPr>
-          <p:cNvPr id="19" name="Text 17"/>
+          <p:cNvPr id="10" name="Text 7"/>
           <p:cNvSpPr txBox="1"/>
           <p:nvPr/>
         </p:nvSpPr>
@@ -5067,7 +5709,7 @@
                 <a:ea typeface="Calibri" pitchFamily="34" charset="-122"/>
                 <a:cs typeface="Calibri" pitchFamily="34" charset="-120"/>
               </a:rPr>
-              <a:t>122 testes automatizados sustentam cada decisão de limpeza.</a:t>
+              <a:t>Marcamos em vez de apagar: a base guarda o problema e a decisão fica auditável.</a:t>
             </a:r>
             <a:endParaRPr lang="en-US" sz="1350" dirty="0"/>
           </a:p>
@@ -5131,7 +5773,7 @@
                 <a:ea typeface="Cambria" pitchFamily="34" charset="-122"/>
                 <a:cs typeface="Cambria" pitchFamily="34" charset="-120"/>
               </a:rPr>
-              <a:t>Ferramentas em cada etapa</a:t>
+              <a:t>PRODUCE — o que foi produzido</a:t>
             </a:r>
             <a:endParaRPr lang="en-US" sz="3000" dirty="0"/>
           </a:p>
@@ -5145,20 +5787,18 @@
         </p:nvSpPr>
         <p:spPr>
           <a:xfrm>
-            <a:off x="502920" y="1170432"/>
-            <a:ext cx="2560320" cy="2788920"/>
-          </a:xfrm>
-          <a:prstGeom prst="roundRect">
-            <a:avLst>
-              <a:gd name="adj" fmla="val 2143"/>
-            </a:avLst>
+            <a:off x="502920" y="1207008"/>
+            <a:ext cx="310896" cy="310896"/>
+          </a:xfrm>
+          <a:prstGeom prst="ellipse">
+            <a:avLst/>
           </a:prstGeom>
           <a:solidFill>
-            <a:srgbClr val="F4F4F2"/>
+            <a:srgbClr val="EB6834"/>
           </a:solidFill>
           <a:ln w="12700">
             <a:solidFill>
-              <a:srgbClr val="F4F4F2"/>
+              <a:srgbClr val="EB6834"/>
             </a:solidFill>
             <a:prstDash val="solid"/>
           </a:ln>
@@ -5172,34 +5812,34 @@
         </p:nvSpPr>
         <p:spPr>
           <a:xfrm>
-            <a:off x="685800" y="1325880"/>
-            <a:ext cx="2194560" cy="292608"/>
-          </a:xfrm>
-          <a:prstGeom prst="rect">
-            <a:avLst/>
-          </a:prstGeom>
-          <a:noFill/>
-          <a:ln/>
-        </p:spPr>
-        <p:txBody>
-          <a:bodyPr wrap="square" lIns="0" tIns="0" rIns="0" bIns="0" rtlCol="0" anchor="ctr"/>
-          <a:lstStyle/>
-          <a:p>
-            <a:pPr indent="0" marL="0">
-              <a:buNone/>
-            </a:pPr>
-            <a:r>
-              <a:rPr lang="en-US" sz="1300" b="1" dirty="0">
-                <a:solidFill>
-                  <a:srgbClr val="2A78D6"/>
-                </a:solidFill>
-                <a:latin typeface="Calibri" pitchFamily="34" charset="0"/>
-                <a:ea typeface="Calibri" pitchFamily="34" charset="-122"/>
-                <a:cs typeface="Calibri" pitchFamily="34" charset="-120"/>
-              </a:rPr>
-              <a:t>EXPLORE</a:t>
-            </a:r>
-            <a:endParaRPr lang="en-US" sz="1300" dirty="0"/>
+            <a:off x="502920" y="1207008"/>
+            <a:ext cx="310896" cy="310896"/>
+          </a:xfrm>
+          <a:prstGeom prst="rect">
+            <a:avLst/>
+          </a:prstGeom>
+          <a:noFill/>
+          <a:ln/>
+        </p:spPr>
+        <p:txBody>
+          <a:bodyPr wrap="square" lIns="0" tIns="0" rIns="0" bIns="0" rtlCol="0" anchor="ctr"/>
+          <a:lstStyle/>
+          <a:p>
+            <a:pPr algn="ctr" indent="0" marL="0">
+              <a:buNone/>
+            </a:pPr>
+            <a:r>
+              <a:rPr lang="en-US" sz="1500" b="1" dirty="0">
+                <a:solidFill>
+                  <a:srgbClr val="FFFFFF"/>
+                </a:solidFill>
+                <a:latin typeface="Calibri" pitchFamily="34" charset="0"/>
+                <a:ea typeface="Calibri" pitchFamily="34" charset="-122"/>
+                <a:cs typeface="Calibri" pitchFamily="34" charset="-120"/>
+              </a:rPr>
+              <a:t>1</a:t>
+            </a:r>
+            <a:endParaRPr lang="en-US" sz="1500" dirty="0"/>
           </a:p>
         </p:txBody>
       </p:sp>
@@ -5211,8 +5851,47 @@
         </p:nvSpPr>
         <p:spPr>
           <a:xfrm>
-            <a:off x="685800" y="1691640"/>
-            <a:ext cx="2194560" cy="274320"/>
+            <a:off x="960120" y="1188720"/>
+            <a:ext cx="2651760" cy="292608"/>
+          </a:xfrm>
+          <a:prstGeom prst="rect">
+            <a:avLst/>
+          </a:prstGeom>
+          <a:noFill/>
+          <a:ln/>
+        </p:spPr>
+        <p:txBody>
+          <a:bodyPr wrap="square" lIns="0" tIns="0" rIns="0" bIns="0" rtlCol="0" anchor="ctr"/>
+          <a:lstStyle/>
+          <a:p>
+            <a:pPr indent="0" marL="0">
+              <a:buNone/>
+            </a:pPr>
+            <a:r>
+              <a:rPr lang="en-US" sz="1400" b="1" dirty="0">
+                <a:solidFill>
+                  <a:srgbClr val="1C1C1E"/>
+                </a:solidFill>
+                <a:latin typeface="Calibri" pitchFamily="34" charset="0"/>
+                <a:ea typeface="Calibri" pitchFamily="34" charset="-122"/>
+                <a:cs typeface="Calibri" pitchFamily="34" charset="-120"/>
+              </a:rPr>
+              <a:t>Base única</a:t>
+            </a:r>
+            <a:endParaRPr lang="en-US" sz="1400" dirty="0"/>
+          </a:p>
+        </p:txBody>
+      </p:sp>
+      <p:sp>
+        <p:nvSpPr>
+          <p:cNvPr id="6" name="Text 4"/>
+          <p:cNvSpPr txBox="1"/>
+          <p:nvPr/>
+        </p:nvSpPr>
+        <p:spPr>
+          <a:xfrm>
+            <a:off x="3657600" y="1207008"/>
+            <a:ext cx="4983480" cy="548640"/>
           </a:xfrm>
           <a:prstGeom prst="rect">
             <a:avLst/>
@@ -5230,13 +5909,13 @@
             <a:r>
               <a:rPr lang="en-US" sz="1250" dirty="0">
                 <a:solidFill>
-                  <a:srgbClr val="1C1C1E"/>
-                </a:solidFill>
-                <a:latin typeface="Calibri" pitchFamily="34" charset="0"/>
-                <a:ea typeface="Calibri" pitchFamily="34" charset="-122"/>
-                <a:cs typeface="Calibri" pitchFamily="34" charset="-120"/>
-              </a:rPr>
-              <a:t>urllib + HTTP Range</a:t>
+                  <a:srgbClr val="6B6A66"/>
+                </a:solidFill>
+                <a:latin typeface="Calibri" pitchFamily="34" charset="0"/>
+                <a:ea typeface="Calibri" pitchFamily="34" charset="-122"/>
+                <a:cs typeface="Calibri" pitchFamily="34" charset="-120"/>
+              </a:rPr>
+              <a:t>3,47 milhões de registros · 1,8 GB de CSV → 94 MB de Parquet</a:t>
             </a:r>
             <a:endParaRPr lang="en-US" sz="1250" dirty="0"/>
           </a:p>
@@ -5244,143 +5923,24 @@
       </p:sp>
       <p:sp>
         <p:nvSpPr>
-          <p:cNvPr id="6" name="Text 4"/>
-          <p:cNvSpPr txBox="1"/>
-          <p:nvPr/>
-        </p:nvSpPr>
-        <p:spPr>
-          <a:xfrm>
-            <a:off x="685800" y="2002536"/>
-            <a:ext cx="2194560" cy="274320"/>
-          </a:xfrm>
-          <a:prstGeom prst="rect">
-            <a:avLst/>
-          </a:prstGeom>
-          <a:noFill/>
-          <a:ln/>
-        </p:spPr>
-        <p:txBody>
-          <a:bodyPr wrap="square" lIns="0" tIns="0" rIns="0" bIns="0" rtlCol="0" anchor="ctr"/>
-          <a:lstStyle/>
-          <a:p>
-            <a:pPr indent="0" marL="0">
-              <a:buNone/>
-            </a:pPr>
-            <a:r>
-              <a:rPr lang="en-US" sz="1250" dirty="0">
-                <a:solidFill>
-                  <a:srgbClr val="1C1C1E"/>
-                </a:solidFill>
-                <a:latin typeface="Calibri" pitchFamily="34" charset="0"/>
-                <a:ea typeface="Calibri" pitchFamily="34" charset="-122"/>
-                <a:cs typeface="Calibri" pitchFamily="34" charset="-120"/>
-              </a:rPr>
-              <a:t>pandas</a:t>
-            </a:r>
-            <a:endParaRPr lang="en-US" sz="1250" dirty="0"/>
-          </a:p>
-        </p:txBody>
-      </p:sp>
-      <p:sp>
-        <p:nvSpPr>
-          <p:cNvPr id="7" name="Text 5"/>
-          <p:cNvSpPr txBox="1"/>
-          <p:nvPr/>
-        </p:nvSpPr>
-        <p:spPr>
-          <a:xfrm>
-            <a:off x="685800" y="2313432"/>
-            <a:ext cx="2194560" cy="274320"/>
-          </a:xfrm>
-          <a:prstGeom prst="rect">
-            <a:avLst/>
-          </a:prstGeom>
-          <a:noFill/>
-          <a:ln/>
-        </p:spPr>
-        <p:txBody>
-          <a:bodyPr wrap="square" lIns="0" tIns="0" rIns="0" bIns="0" rtlCol="0" anchor="ctr"/>
-          <a:lstStyle/>
-          <a:p>
-            <a:pPr indent="0" marL="0">
-              <a:buNone/>
-            </a:pPr>
-            <a:r>
-              <a:rPr lang="en-US" sz="1250" dirty="0">
-                <a:solidFill>
-                  <a:srgbClr val="1C1C1E"/>
-                </a:solidFill>
-                <a:latin typeface="Calibri" pitchFamily="34" charset="0"/>
-                <a:ea typeface="Calibri" pitchFamily="34" charset="-122"/>
-                <a:cs typeface="Calibri" pitchFamily="34" charset="-120"/>
-              </a:rPr>
-              <a:t>PyArrow</a:t>
-            </a:r>
-            <a:endParaRPr lang="en-US" sz="1250" dirty="0"/>
-          </a:p>
-        </p:txBody>
-      </p:sp>
-      <p:sp>
-        <p:nvSpPr>
-          <p:cNvPr id="8" name="Text 6"/>
-          <p:cNvSpPr txBox="1"/>
-          <p:nvPr/>
-        </p:nvSpPr>
-        <p:spPr>
-          <a:xfrm>
-            <a:off x="685800" y="2743200"/>
-            <a:ext cx="2194560" cy="1051560"/>
-          </a:xfrm>
-          <a:prstGeom prst="rect">
-            <a:avLst/>
-          </a:prstGeom>
-          <a:noFill/>
-          <a:ln/>
-        </p:spPr>
-        <p:txBody>
-          <a:bodyPr wrap="square" lIns="0" tIns="0" rIns="0" bIns="0" rtlCol="0" anchor="ctr"/>
-          <a:lstStyle/>
-          <a:p>
-            <a:pPr indent="0" marL="0">
-              <a:buNone/>
-            </a:pPr>
-            <a:r>
-              <a:rPr lang="en-US" sz="1150" dirty="0">
-                <a:solidFill>
-                  <a:srgbClr val="6B6A66"/>
-                </a:solidFill>
-                <a:latin typeface="Calibri" pitchFamily="34" charset="0"/>
-                <a:ea typeface="Calibri" pitchFamily="34" charset="-122"/>
-                <a:cs typeface="Calibri" pitchFamily="34" charset="-120"/>
-              </a:rPr>
-              <a:t>ler cabeçalhos sem baixar tudo; perfilar domínios e nulos</a:t>
-            </a:r>
-            <a:endParaRPr lang="en-US" sz="1150" dirty="0"/>
-          </a:p>
-        </p:txBody>
-      </p:sp>
-      <p:sp>
-        <p:nvSpPr>
-          <p:cNvPr id="9" name="Shape 7"/>
+          <p:cNvPr id="7" name="Shape 5"/>
           <p:cNvSpPr/>
           <p:nvPr/>
         </p:nvSpPr>
         <p:spPr>
           <a:xfrm>
-            <a:off x="3291840" y="1170432"/>
-            <a:ext cx="2560320" cy="2788920"/>
-          </a:xfrm>
-          <a:prstGeom prst="roundRect">
-            <a:avLst>
-              <a:gd name="adj" fmla="val 2143"/>
-            </a:avLst>
+            <a:off x="502920" y="1956816"/>
+            <a:ext cx="310896" cy="310896"/>
+          </a:xfrm>
+          <a:prstGeom prst="ellipse">
+            <a:avLst/>
           </a:prstGeom>
           <a:solidFill>
-            <a:srgbClr val="F4F4F2"/>
+            <a:srgbClr val="EB6834"/>
           </a:solidFill>
           <a:ln w="12700">
             <a:solidFill>
-              <a:srgbClr val="F4F4F2"/>
+              <a:srgbClr val="EB6834"/>
             </a:solidFill>
             <a:prstDash val="solid"/>
           </a:ln>
@@ -5388,53 +5948,92 @@
       </p:sp>
       <p:sp>
         <p:nvSpPr>
+          <p:cNvPr id="8" name="Text 6"/>
+          <p:cNvSpPr txBox="1"/>
+          <p:nvPr/>
+        </p:nvSpPr>
+        <p:spPr>
+          <a:xfrm>
+            <a:off x="502920" y="1956816"/>
+            <a:ext cx="310896" cy="310896"/>
+          </a:xfrm>
+          <a:prstGeom prst="rect">
+            <a:avLst/>
+          </a:prstGeom>
+          <a:noFill/>
+          <a:ln/>
+        </p:spPr>
+        <p:txBody>
+          <a:bodyPr wrap="square" lIns="0" tIns="0" rIns="0" bIns="0" rtlCol="0" anchor="ctr"/>
+          <a:lstStyle/>
+          <a:p>
+            <a:pPr algn="ctr" indent="0" marL="0">
+              <a:buNone/>
+            </a:pPr>
+            <a:r>
+              <a:rPr lang="en-US" sz="1500" b="1" dirty="0">
+                <a:solidFill>
+                  <a:srgbClr val="FFFFFF"/>
+                </a:solidFill>
+                <a:latin typeface="Calibri" pitchFamily="34" charset="0"/>
+                <a:ea typeface="Calibri" pitchFamily="34" charset="-122"/>
+                <a:cs typeface="Calibri" pitchFamily="34" charset="-120"/>
+              </a:rPr>
+              <a:t>2</a:t>
+            </a:r>
+            <a:endParaRPr lang="en-US" sz="1500" dirty="0"/>
+          </a:p>
+        </p:txBody>
+      </p:sp>
+      <p:sp>
+        <p:nvSpPr>
+          <p:cNvPr id="9" name="Text 7"/>
+          <p:cNvSpPr txBox="1"/>
+          <p:nvPr/>
+        </p:nvSpPr>
+        <p:spPr>
+          <a:xfrm>
+            <a:off x="960120" y="1938528"/>
+            <a:ext cx="2651760" cy="292608"/>
+          </a:xfrm>
+          <a:prstGeom prst="rect">
+            <a:avLst/>
+          </a:prstGeom>
+          <a:noFill/>
+          <a:ln/>
+        </p:spPr>
+        <p:txBody>
+          <a:bodyPr wrap="square" lIns="0" tIns="0" rIns="0" bIns="0" rtlCol="0" anchor="ctr"/>
+          <a:lstStyle/>
+          <a:p>
+            <a:pPr indent="0" marL="0">
+              <a:buNone/>
+            </a:pPr>
+            <a:r>
+              <a:rPr lang="en-US" sz="1400" b="1" dirty="0">
+                <a:solidFill>
+                  <a:srgbClr val="1C1C1E"/>
+                </a:solidFill>
+                <a:latin typeface="Calibri" pitchFamily="34" charset="0"/>
+                <a:ea typeface="Calibri" pitchFamily="34" charset="-122"/>
+                <a:cs typeface="Calibri" pitchFamily="34" charset="-120"/>
+              </a:rPr>
+              <a:t>Pipeline reproduzível</a:t>
+            </a:r>
+            <a:endParaRPr lang="en-US" sz="1400" dirty="0"/>
+          </a:p>
+        </p:txBody>
+      </p:sp>
+      <p:sp>
+        <p:nvSpPr>
           <p:cNvPr id="10" name="Text 8"/>
           <p:cNvSpPr txBox="1"/>
           <p:nvPr/>
         </p:nvSpPr>
         <p:spPr>
           <a:xfrm>
-            <a:off x="3474720" y="1325880"/>
-            <a:ext cx="2194560" cy="292608"/>
-          </a:xfrm>
-          <a:prstGeom prst="rect">
-            <a:avLst/>
-          </a:prstGeom>
-          <a:noFill/>
-          <a:ln/>
-        </p:spPr>
-        <p:txBody>
-          <a:bodyPr wrap="square" lIns="0" tIns="0" rIns="0" bIns="0" rtlCol="0" anchor="ctr"/>
-          <a:lstStyle/>
-          <a:p>
-            <a:pPr indent="0" marL="0">
-              <a:buNone/>
-            </a:pPr>
-            <a:r>
-              <a:rPr lang="en-US" sz="1300" b="1" dirty="0">
-                <a:solidFill>
-                  <a:srgbClr val="EB6834"/>
-                </a:solidFill>
-                <a:latin typeface="Calibri" pitchFamily="34" charset="0"/>
-                <a:ea typeface="Calibri" pitchFamily="34" charset="-122"/>
-                <a:cs typeface="Calibri" pitchFamily="34" charset="-120"/>
-              </a:rPr>
-              <a:t>REFINE</a:t>
-            </a:r>
-            <a:endParaRPr lang="en-US" sz="1300" dirty="0"/>
-          </a:p>
-        </p:txBody>
-      </p:sp>
-      <p:sp>
-        <p:nvSpPr>
-          <p:cNvPr id="11" name="Text 9"/>
-          <p:cNvSpPr txBox="1"/>
-          <p:nvPr/>
-        </p:nvSpPr>
-        <p:spPr>
-          <a:xfrm>
-            <a:off x="3474720" y="1691640"/>
-            <a:ext cx="2194560" cy="274320"/>
+            <a:off x="3657600" y="1956816"/>
+            <a:ext cx="4983480" cy="548640"/>
           </a:xfrm>
           <a:prstGeom prst="rect">
             <a:avLst/>
@@ -5452,13 +6051,13 @@
             <a:r>
               <a:rPr lang="en-US" sz="1250" dirty="0">
                 <a:solidFill>
-                  <a:srgbClr val="1C1C1E"/>
-                </a:solidFill>
-                <a:latin typeface="Calibri" pitchFamily="34" charset="0"/>
-                <a:ea typeface="Calibri" pitchFamily="34" charset="-122"/>
-                <a:cs typeface="Calibri" pitchFamily="34" charset="-120"/>
-              </a:rPr>
-              <a:t>pandas</a:t>
+                  <a:srgbClr val="6B6A66"/>
+                </a:solidFill>
+                <a:latin typeface="Calibri" pitchFamily="34" charset="0"/>
+                <a:ea typeface="Calibri" pitchFamily="34" charset="-122"/>
+                <a:cs typeface="Calibri" pitchFamily="34" charset="-120"/>
+              </a:rPr>
+              <a:t>quatro etapas retomáveis · reconstrói tudo em 2 minutos</a:t>
             </a:r>
             <a:endParaRPr lang="en-US" sz="1250" dirty="0"/>
           </a:p>
@@ -5466,143 +6065,24 @@
       </p:sp>
       <p:sp>
         <p:nvSpPr>
-          <p:cNvPr id="12" name="Text 10"/>
-          <p:cNvSpPr txBox="1"/>
-          <p:nvPr/>
-        </p:nvSpPr>
-        <p:spPr>
-          <a:xfrm>
-            <a:off x="3474720" y="2002536"/>
-            <a:ext cx="2194560" cy="274320"/>
-          </a:xfrm>
-          <a:prstGeom prst="rect">
-            <a:avLst/>
-          </a:prstGeom>
-          <a:noFill/>
-          <a:ln/>
-        </p:spPr>
-        <p:txBody>
-          <a:bodyPr wrap="square" lIns="0" tIns="0" rIns="0" bIns="0" rtlCol="0" anchor="ctr"/>
-          <a:lstStyle/>
-          <a:p>
-            <a:pPr indent="0" marL="0">
-              <a:buNone/>
-            </a:pPr>
-            <a:r>
-              <a:rPr lang="en-US" sz="1250" dirty="0">
-                <a:solidFill>
-                  <a:srgbClr val="1C1C1E"/>
-                </a:solidFill>
-                <a:latin typeface="Calibri" pitchFamily="34" charset="0"/>
-                <a:ea typeface="Calibri" pitchFamily="34" charset="-122"/>
-                <a:cs typeface="Calibri" pitchFamily="34" charset="-120"/>
-              </a:rPr>
-              <a:t>pytest</a:t>
-            </a:r>
-            <a:endParaRPr lang="en-US" sz="1250" dirty="0"/>
-          </a:p>
-        </p:txBody>
-      </p:sp>
-      <p:sp>
-        <p:nvSpPr>
-          <p:cNvPr id="13" name="Text 11"/>
-          <p:cNvSpPr txBox="1"/>
-          <p:nvPr/>
-        </p:nvSpPr>
-        <p:spPr>
-          <a:xfrm>
-            <a:off x="3474720" y="2313432"/>
-            <a:ext cx="2194560" cy="274320"/>
-          </a:xfrm>
-          <a:prstGeom prst="rect">
-            <a:avLst/>
-          </a:prstGeom>
-          <a:noFill/>
-          <a:ln/>
-        </p:spPr>
-        <p:txBody>
-          <a:bodyPr wrap="square" lIns="0" tIns="0" rIns="0" bIns="0" rtlCol="0" anchor="ctr"/>
-          <a:lstStyle/>
-          <a:p>
-            <a:pPr indent="0" marL="0">
-              <a:buNone/>
-            </a:pPr>
-            <a:r>
-              <a:rPr lang="en-US" sz="1250" dirty="0">
-                <a:solidFill>
-                  <a:srgbClr val="1C1C1E"/>
-                </a:solidFill>
-                <a:latin typeface="Calibri" pitchFamily="34" charset="0"/>
-                <a:ea typeface="Calibri" pitchFamily="34" charset="-122"/>
-                <a:cs typeface="Calibri" pitchFamily="34" charset="-120"/>
-              </a:rPr>
-              <a:t>ruff</a:t>
-            </a:r>
-            <a:endParaRPr lang="en-US" sz="1250" dirty="0"/>
-          </a:p>
-        </p:txBody>
-      </p:sp>
-      <p:sp>
-        <p:nvSpPr>
-          <p:cNvPr id="14" name="Text 12"/>
-          <p:cNvSpPr txBox="1"/>
-          <p:nvPr/>
-        </p:nvSpPr>
-        <p:spPr>
-          <a:xfrm>
-            <a:off x="3474720" y="2743200"/>
-            <a:ext cx="2194560" cy="1051560"/>
-          </a:xfrm>
-          <a:prstGeom prst="rect">
-            <a:avLst/>
-          </a:prstGeom>
-          <a:noFill/>
-          <a:ln/>
-        </p:spPr>
-        <p:txBody>
-          <a:bodyPr wrap="square" lIns="0" tIns="0" rIns="0" bIns="0" rtlCol="0" anchor="ctr"/>
-          <a:lstStyle/>
-          <a:p>
-            <a:pPr indent="0" marL="0">
-              <a:buNone/>
-            </a:pPr>
-            <a:r>
-              <a:rPr lang="en-US" sz="1150" dirty="0">
-                <a:solidFill>
-                  <a:srgbClr val="6B6A66"/>
-                </a:solidFill>
-                <a:latin typeface="Calibri" pitchFamily="34" charset="0"/>
-                <a:ea typeface="Calibri" pitchFamily="34" charset="-122"/>
-                <a:cs typeface="Calibri" pitchFamily="34" charset="-120"/>
-              </a:rPr>
-              <a:t>normalizar os 4 formatos; cada decisão com teste que a fixa</a:t>
-            </a:r>
-            <a:endParaRPr lang="en-US" sz="1150" dirty="0"/>
-          </a:p>
-        </p:txBody>
-      </p:sp>
-      <p:sp>
-        <p:nvSpPr>
-          <p:cNvPr id="15" name="Shape 13"/>
+          <p:cNvPr id="11" name="Shape 9"/>
           <p:cNvSpPr/>
           <p:nvPr/>
         </p:nvSpPr>
         <p:spPr>
           <a:xfrm>
-            <a:off x="6080760" y="1170432"/>
-            <a:ext cx="2560320" cy="2788920"/>
-          </a:xfrm>
-          <a:prstGeom prst="roundRect">
-            <a:avLst>
-              <a:gd name="adj" fmla="val 2143"/>
-            </a:avLst>
+            <a:off x="502920" y="2706624"/>
+            <a:ext cx="310896" cy="310896"/>
+          </a:xfrm>
+          <a:prstGeom prst="ellipse">
+            <a:avLst/>
           </a:prstGeom>
           <a:solidFill>
-            <a:srgbClr val="F4F4F2"/>
+            <a:srgbClr val="EB6834"/>
           </a:solidFill>
           <a:ln w="12700">
             <a:solidFill>
-              <a:srgbClr val="F4F4F2"/>
+              <a:srgbClr val="EB6834"/>
             </a:solidFill>
             <a:prstDash val="solid"/>
           </a:ln>
@@ -5610,40 +6090,182 @@
       </p:sp>
       <p:sp>
         <p:nvSpPr>
+          <p:cNvPr id="12" name="Text 10"/>
+          <p:cNvSpPr txBox="1"/>
+          <p:nvPr/>
+        </p:nvSpPr>
+        <p:spPr>
+          <a:xfrm>
+            <a:off x="502920" y="2706624"/>
+            <a:ext cx="310896" cy="310896"/>
+          </a:xfrm>
+          <a:prstGeom prst="rect">
+            <a:avLst/>
+          </a:prstGeom>
+          <a:noFill/>
+          <a:ln/>
+        </p:spPr>
+        <p:txBody>
+          <a:bodyPr wrap="square" lIns="0" tIns="0" rIns="0" bIns="0" rtlCol="0" anchor="ctr"/>
+          <a:lstStyle/>
+          <a:p>
+            <a:pPr algn="ctr" indent="0" marL="0">
+              <a:buNone/>
+            </a:pPr>
+            <a:r>
+              <a:rPr lang="en-US" sz="1500" b="1" dirty="0">
+                <a:solidFill>
+                  <a:srgbClr val="FFFFFF"/>
+                </a:solidFill>
+                <a:latin typeface="Calibri" pitchFamily="34" charset="0"/>
+                <a:ea typeface="Calibri" pitchFamily="34" charset="-122"/>
+                <a:cs typeface="Calibri" pitchFamily="34" charset="-120"/>
+              </a:rPr>
+              <a:t>3</a:t>
+            </a:r>
+            <a:endParaRPr lang="en-US" sz="1500" dirty="0"/>
+          </a:p>
+        </p:txBody>
+      </p:sp>
+      <p:sp>
+        <p:nvSpPr>
+          <p:cNvPr id="13" name="Text 11"/>
+          <p:cNvSpPr txBox="1"/>
+          <p:nvPr/>
+        </p:nvSpPr>
+        <p:spPr>
+          <a:xfrm>
+            <a:off x="960120" y="2688336"/>
+            <a:ext cx="2651760" cy="292608"/>
+          </a:xfrm>
+          <a:prstGeom prst="rect">
+            <a:avLst/>
+          </a:prstGeom>
+          <a:noFill/>
+          <a:ln/>
+        </p:spPr>
+        <p:txBody>
+          <a:bodyPr wrap="square" lIns="0" tIns="0" rIns="0" bIns="0" rtlCol="0" anchor="ctr"/>
+          <a:lstStyle/>
+          <a:p>
+            <a:pPr indent="0" marL="0">
+              <a:buNone/>
+            </a:pPr>
+            <a:r>
+              <a:rPr lang="en-US" sz="1400" b="1" dirty="0">
+                <a:solidFill>
+                  <a:srgbClr val="1C1C1E"/>
+                </a:solidFill>
+                <a:latin typeface="Calibri" pitchFamily="34" charset="0"/>
+                <a:ea typeface="Calibri" pitchFamily="34" charset="-122"/>
+                <a:cs typeface="Calibri" pitchFamily="34" charset="-120"/>
+              </a:rPr>
+              <a:t>Relatório automatizado</a:t>
+            </a:r>
+            <a:endParaRPr lang="en-US" sz="1400" dirty="0"/>
+          </a:p>
+        </p:txBody>
+      </p:sp>
+      <p:sp>
+        <p:nvSpPr>
+          <p:cNvPr id="14" name="Text 12"/>
+          <p:cNvSpPr txBox="1"/>
+          <p:nvPr/>
+        </p:nvSpPr>
+        <p:spPr>
+          <a:xfrm>
+            <a:off x="3657600" y="2706624"/>
+            <a:ext cx="4983480" cy="548640"/>
+          </a:xfrm>
+          <a:prstGeom prst="rect">
+            <a:avLst/>
+          </a:prstGeom>
+          <a:noFill/>
+          <a:ln/>
+        </p:spPr>
+        <p:txBody>
+          <a:bodyPr wrap="square" lIns="0" tIns="0" rIns="0" bIns="0" rtlCol="0" anchor="ctr"/>
+          <a:lstStyle/>
+          <a:p>
+            <a:pPr indent="0" marL="0">
+              <a:buNone/>
+            </a:pPr>
+            <a:r>
+              <a:rPr lang="en-US" sz="1250" dirty="0">
+                <a:solidFill>
+                  <a:srgbClr val="6B6A66"/>
+                </a:solidFill>
+                <a:latin typeface="Calibri" pitchFamily="34" charset="0"/>
+                <a:ea typeface="Calibri" pitchFamily="34" charset="-122"/>
+                <a:cs typeface="Calibri" pitchFamily="34" charset="-120"/>
+              </a:rPr>
+              <a:t>volume, cobertura, domínios e consistência, regerado por comando</a:t>
+            </a:r>
+            <a:endParaRPr lang="en-US" sz="1250" dirty="0"/>
+          </a:p>
+        </p:txBody>
+      </p:sp>
+      <p:sp>
+        <p:nvSpPr>
+          <p:cNvPr id="15" name="Shape 13"/>
+          <p:cNvSpPr/>
+          <p:nvPr/>
+        </p:nvSpPr>
+        <p:spPr>
+          <a:xfrm>
+            <a:off x="502920" y="3456432"/>
+            <a:ext cx="310896" cy="310896"/>
+          </a:xfrm>
+          <a:prstGeom prst="ellipse">
+            <a:avLst/>
+          </a:prstGeom>
+          <a:solidFill>
+            <a:srgbClr val="EB6834"/>
+          </a:solidFill>
+          <a:ln w="12700">
+            <a:solidFill>
+              <a:srgbClr val="EB6834"/>
+            </a:solidFill>
+            <a:prstDash val="solid"/>
+          </a:ln>
+        </p:spPr>
+      </p:sp>
+      <p:sp>
+        <p:nvSpPr>
           <p:cNvPr id="16" name="Text 14"/>
           <p:cNvSpPr txBox="1"/>
           <p:nvPr/>
         </p:nvSpPr>
         <p:spPr>
           <a:xfrm>
-            <a:off x="6263640" y="1325880"/>
-            <a:ext cx="2194560" cy="292608"/>
-          </a:xfrm>
-          <a:prstGeom prst="rect">
-            <a:avLst/>
-          </a:prstGeom>
-          <a:noFill/>
-          <a:ln/>
-        </p:spPr>
-        <p:txBody>
-          <a:bodyPr wrap="square" lIns="0" tIns="0" rIns="0" bIns="0" rtlCol="0" anchor="ctr"/>
-          <a:lstStyle/>
-          <a:p>
-            <a:pPr indent="0" marL="0">
-              <a:buNone/>
-            </a:pPr>
-            <a:r>
-              <a:rPr lang="en-US" sz="1300" b="1" dirty="0">
-                <a:solidFill>
-                  <a:srgbClr val="1BAF7A"/>
-                </a:solidFill>
-                <a:latin typeface="Calibri" pitchFamily="34" charset="0"/>
-                <a:ea typeface="Calibri" pitchFamily="34" charset="-122"/>
-                <a:cs typeface="Calibri" pitchFamily="34" charset="-120"/>
-              </a:rPr>
-              <a:t>PRODUCE</a:t>
-            </a:r>
-            <a:endParaRPr lang="en-US" sz="1300" dirty="0"/>
+            <a:off x="502920" y="3456432"/>
+            <a:ext cx="310896" cy="310896"/>
+          </a:xfrm>
+          <a:prstGeom prst="rect">
+            <a:avLst/>
+          </a:prstGeom>
+          <a:noFill/>
+          <a:ln/>
+        </p:spPr>
+        <p:txBody>
+          <a:bodyPr wrap="square" lIns="0" tIns="0" rIns="0" bIns="0" rtlCol="0" anchor="ctr"/>
+          <a:lstStyle/>
+          <a:p>
+            <a:pPr algn="ctr" indent="0" marL="0">
+              <a:buNone/>
+            </a:pPr>
+            <a:r>
+              <a:rPr lang="en-US" sz="1500" b="1" dirty="0">
+                <a:solidFill>
+                  <a:srgbClr val="FFFFFF"/>
+                </a:solidFill>
+                <a:latin typeface="Calibri" pitchFamily="34" charset="0"/>
+                <a:ea typeface="Calibri" pitchFamily="34" charset="-122"/>
+                <a:cs typeface="Calibri" pitchFamily="34" charset="-120"/>
+              </a:rPr>
+              <a:t>4</a:t>
+            </a:r>
+            <a:endParaRPr lang="en-US" sz="1500" dirty="0"/>
           </a:p>
         </p:txBody>
       </p:sp>
@@ -5655,8 +6277,47 @@
         </p:nvSpPr>
         <p:spPr>
           <a:xfrm>
-            <a:off x="6263640" y="1691640"/>
-            <a:ext cx="2194560" cy="274320"/>
+            <a:off x="960120" y="3438144"/>
+            <a:ext cx="2651760" cy="292608"/>
+          </a:xfrm>
+          <a:prstGeom prst="rect">
+            <a:avLst/>
+          </a:prstGeom>
+          <a:noFill/>
+          <a:ln/>
+        </p:spPr>
+        <p:txBody>
+          <a:bodyPr wrap="square" lIns="0" tIns="0" rIns="0" bIns="0" rtlCol="0" anchor="ctr"/>
+          <a:lstStyle/>
+          <a:p>
+            <a:pPr indent="0" marL="0">
+              <a:buNone/>
+            </a:pPr>
+            <a:r>
+              <a:rPr lang="en-US" sz="1400" b="1" dirty="0">
+                <a:solidFill>
+                  <a:srgbClr val="1C1C1E"/>
+                </a:solidFill>
+                <a:latin typeface="Calibri" pitchFamily="34" charset="0"/>
+                <a:ea typeface="Calibri" pitchFamily="34" charset="-122"/>
+                <a:cs typeface="Calibri" pitchFamily="34" charset="-120"/>
+              </a:rPr>
+              <a:t>Notebook no Colab</a:t>
+            </a:r>
+            <a:endParaRPr lang="en-US" sz="1400" dirty="0"/>
+          </a:p>
+        </p:txBody>
+      </p:sp>
+      <p:sp>
+        <p:nvSpPr>
+          <p:cNvPr id="18" name="Text 16"/>
+          <p:cNvSpPr txBox="1"/>
+          <p:nvPr/>
+        </p:nvSpPr>
+        <p:spPr>
+          <a:xfrm>
+            <a:off x="3657600" y="3456432"/>
+            <a:ext cx="4983480" cy="548640"/>
           </a:xfrm>
           <a:prstGeom prst="rect">
             <a:avLst/>
@@ -5674,13 +6335,13 @@
             <a:r>
               <a:rPr lang="en-US" sz="1250" dirty="0">
                 <a:solidFill>
-                  <a:srgbClr val="1C1C1E"/>
-                </a:solidFill>
-                <a:latin typeface="Calibri" pitchFamily="34" charset="0"/>
-                <a:ea typeface="Calibri" pitchFamily="34" charset="-122"/>
-                <a:cs typeface="Calibri" pitchFamily="34" charset="-120"/>
-              </a:rPr>
-              <a:t>Parquet + zstd</a:t>
+                  <a:srgbClr val="6B6A66"/>
+                </a:solidFill>
+                <a:latin typeface="Calibri" pitchFamily="34" charset="0"/>
+                <a:ea typeface="Calibri" pitchFamily="34" charset="-122"/>
+                <a:cs typeface="Calibri" pitchFamily="34" charset="-120"/>
+              </a:rPr>
+              <a:t>a consolidação explicada passo a passo, executável por qualquer um</a:t>
             </a:r>
             <a:endParaRPr lang="en-US" sz="1250" dirty="0"/>
           </a:p>
@@ -5688,157 +6349,40 @@
       </p:sp>
       <p:sp>
         <p:nvSpPr>
-          <p:cNvPr id="18" name="Text 16"/>
-          <p:cNvSpPr txBox="1"/>
-          <p:nvPr/>
-        </p:nvSpPr>
-        <p:spPr>
-          <a:xfrm>
-            <a:off x="6263640" y="2002536"/>
-            <a:ext cx="2194560" cy="274320"/>
-          </a:xfrm>
-          <a:prstGeom prst="rect">
-            <a:avLst/>
-          </a:prstGeom>
-          <a:noFill/>
-          <a:ln/>
-        </p:spPr>
-        <p:txBody>
-          <a:bodyPr wrap="square" lIns="0" tIns="0" rIns="0" bIns="0" rtlCol="0" anchor="ctr"/>
-          <a:lstStyle/>
-          <a:p>
-            <a:pPr indent="0" marL="0">
-              <a:buNone/>
-            </a:pPr>
-            <a:r>
-              <a:rPr lang="en-US" sz="1250" dirty="0">
-                <a:solidFill>
-                  <a:srgbClr val="1C1C1E"/>
-                </a:solidFill>
-                <a:latin typeface="Calibri" pitchFamily="34" charset="0"/>
-                <a:ea typeface="Calibri" pitchFamily="34" charset="-122"/>
-                <a:cs typeface="Calibri" pitchFamily="34" charset="-120"/>
-              </a:rPr>
-              <a:t>matplotlib</a:t>
-            </a:r>
-            <a:endParaRPr lang="en-US" sz="1250" dirty="0"/>
-          </a:p>
-        </p:txBody>
-      </p:sp>
-      <p:sp>
-        <p:nvSpPr>
           <p:cNvPr id="19" name="Text 17"/>
           <p:cNvSpPr txBox="1"/>
           <p:nvPr/>
         </p:nvSpPr>
         <p:spPr>
           <a:xfrm>
-            <a:off x="6263640" y="2313432"/>
-            <a:ext cx="2194560" cy="274320"/>
-          </a:xfrm>
-          <a:prstGeom prst="rect">
-            <a:avLst/>
-          </a:prstGeom>
-          <a:noFill/>
-          <a:ln/>
-        </p:spPr>
-        <p:txBody>
-          <a:bodyPr wrap="square" lIns="0" tIns="0" rIns="0" bIns="0" rtlCol="0" anchor="ctr"/>
-          <a:lstStyle/>
-          <a:p>
-            <a:pPr indent="0" marL="0">
-              <a:buNone/>
-            </a:pPr>
-            <a:r>
-              <a:rPr lang="en-US" sz="1250" dirty="0">
-                <a:solidFill>
-                  <a:srgbClr val="1C1C1E"/>
-                </a:solidFill>
-                <a:latin typeface="Calibri" pitchFamily="34" charset="0"/>
-                <a:ea typeface="Calibri" pitchFamily="34" charset="-122"/>
-                <a:cs typeface="Calibri" pitchFamily="34" charset="-120"/>
-              </a:rPr>
-              <a:t>Colab · Git</a:t>
-            </a:r>
-            <a:endParaRPr lang="en-US" sz="1250" dirty="0"/>
-          </a:p>
-        </p:txBody>
-      </p:sp>
-      <p:sp>
-        <p:nvSpPr>
-          <p:cNvPr id="20" name="Text 18"/>
-          <p:cNvSpPr txBox="1"/>
-          <p:nvPr/>
-        </p:nvSpPr>
-        <p:spPr>
-          <a:xfrm>
-            <a:off x="6263640" y="2743200"/>
-            <a:ext cx="2194560" cy="1051560"/>
-          </a:xfrm>
-          <a:prstGeom prst="rect">
-            <a:avLst/>
-          </a:prstGeom>
-          <a:noFill/>
-          <a:ln/>
-        </p:spPr>
-        <p:txBody>
-          <a:bodyPr wrap="square" lIns="0" tIns="0" rIns="0" bIns="0" rtlCol="0" anchor="ctr"/>
-          <a:lstStyle/>
-          <a:p>
-            <a:pPr indent="0" marL="0">
-              <a:buNone/>
-            </a:pPr>
-            <a:r>
-              <a:rPr lang="en-US" sz="1150" dirty="0">
-                <a:solidFill>
-                  <a:srgbClr val="6B6A66"/>
-                </a:solidFill>
-                <a:latin typeface="Calibri" pitchFamily="34" charset="0"/>
-                <a:ea typeface="Calibri" pitchFamily="34" charset="-122"/>
-                <a:cs typeface="Calibri" pitchFamily="34" charset="-120"/>
-              </a:rPr>
-              <a:t>base consolidada, figuras e notebook reproduzível</a:t>
-            </a:r>
-            <a:endParaRPr lang="en-US" sz="1150" dirty="0"/>
-          </a:p>
-        </p:txBody>
-      </p:sp>
-      <p:sp>
-        <p:nvSpPr>
-          <p:cNvPr id="21" name="Text 19"/>
-          <p:cNvSpPr txBox="1"/>
-          <p:nvPr/>
-        </p:nvSpPr>
-        <p:spPr>
-          <a:xfrm>
-            <a:off x="502920" y="4160520"/>
-            <a:ext cx="8138160" cy="502920"/>
-          </a:xfrm>
-          <a:prstGeom prst="rect">
-            <a:avLst/>
-          </a:prstGeom>
-          <a:noFill/>
-          <a:ln/>
-        </p:spPr>
-        <p:txBody>
-          <a:bodyPr wrap="square" lIns="0" tIns="0" rIns="0" bIns="0" rtlCol="0" anchor="ctr"/>
-          <a:lstStyle/>
-          <a:p>
-            <a:pPr indent="0" marL="0">
-              <a:buNone/>
-            </a:pPr>
-            <a:r>
-              <a:rPr lang="en-US" sz="1300" dirty="0">
-                <a:solidFill>
-                  <a:srgbClr val="1C1C1E"/>
-                </a:solidFill>
-                <a:latin typeface="Calibri" pitchFamily="34" charset="0"/>
-                <a:ea typeface="Calibri" pitchFamily="34" charset="-122"/>
-                <a:cs typeface="Calibri" pitchFamily="34" charset="-120"/>
-              </a:rPr>
-              <a:t>Python em todas as etapas. O que mudou foi o papel: explorar com requisições leves, refinar com testes, produzir com formato colunar.</a:t>
-            </a:r>
-            <a:endParaRPr lang="en-US" sz="1300" dirty="0"/>
+            <a:off x="502920" y="4315968"/>
+            <a:ext cx="8138160" cy="411480"/>
+          </a:xfrm>
+          <a:prstGeom prst="rect">
+            <a:avLst/>
+          </a:prstGeom>
+          <a:noFill/>
+          <a:ln/>
+        </p:spPr>
+        <p:txBody>
+          <a:bodyPr wrap="square" lIns="0" tIns="0" rIns="0" bIns="0" rtlCol="0" anchor="ctr"/>
+          <a:lstStyle/>
+          <a:p>
+            <a:pPr indent="0" marL="0">
+              <a:buNone/>
+            </a:pPr>
+            <a:r>
+              <a:rPr lang="en-US" sz="1350" i="1" dirty="0">
+                <a:solidFill>
+                  <a:srgbClr val="EB6834"/>
+                </a:solidFill>
+                <a:latin typeface="Calibri" pitchFamily="34" charset="0"/>
+                <a:ea typeface="Calibri" pitchFamily="34" charset="-122"/>
+                <a:cs typeface="Calibri" pitchFamily="34" charset="-120"/>
+              </a:rPr>
+              <a:t>122 testes automatizados sustentam cada decisão de limpeza.</a:t>
+            </a:r>
+            <a:endParaRPr lang="en-US" sz="1350" dirty="0"/>
           </a:p>
         </p:txBody>
       </p:sp>
@@ -5900,62 +6444,704 @@
                 <a:ea typeface="Cambria" pitchFamily="34" charset="-122"/>
                 <a:cs typeface="Cambria" pitchFamily="34" charset="-120"/>
               </a:rPr>
-              <a:t>Principais resultados: trajeto mata mais</a:t>
+              <a:t>Ferramentas em cada etapa</a:t>
             </a:r>
             <a:endParaRPr lang="en-US" sz="3000" dirty="0"/>
           </a:p>
         </p:txBody>
       </p:sp>
-      <p:pic>
-        <p:nvPicPr>
-          <p:cNvPr id="3" name="Image 0" descr="/home/user/ufpr-ppgcd-acidentes-no-trabalho/reports/apresentacao/figuras/letalidade.png">    </p:cNvPr>
-          <p:cNvPicPr>
-            <a:picLocks noChangeAspect="1"/>
-          </p:cNvPicPr>
-          <p:nvPr/>
-        </p:nvPicPr>
-        <p:blipFill>
-          <a:blip r:embed="rId1"/>
-          <a:stretch>
-            <a:fillRect/>
-          </a:stretch>
-        </p:blipFill>
-        <p:spPr>
-          <a:xfrm>
-            <a:off x="502920" y="1097280"/>
-            <a:ext cx="8138160" cy="3010788"/>
-          </a:xfrm>
-          <a:prstGeom prst="rect">
-            <a:avLst/>
-          </a:prstGeom>
-        </p:spPr>
-      </p:pic>
-      <p:sp>
-        <p:nvSpPr>
-          <p:cNvPr id="4" name="Text 1"/>
+      <p:sp>
+        <p:nvSpPr>
+          <p:cNvPr id="3" name="Shape 1"/>
+          <p:cNvSpPr/>
+          <p:nvPr/>
+        </p:nvSpPr>
+        <p:spPr>
+          <a:xfrm>
+            <a:off x="502920" y="1170432"/>
+            <a:ext cx="2560320" cy="2788920"/>
+          </a:xfrm>
+          <a:prstGeom prst="roundRect">
+            <a:avLst>
+              <a:gd name="adj" fmla="val 2143"/>
+            </a:avLst>
+          </a:prstGeom>
+          <a:solidFill>
+            <a:srgbClr val="F4F4F2"/>
+          </a:solidFill>
+          <a:ln w="12700">
+            <a:solidFill>
+              <a:srgbClr val="F4F4F2"/>
+            </a:solidFill>
+            <a:prstDash val="solid"/>
+          </a:ln>
+        </p:spPr>
+      </p:sp>
+      <p:sp>
+        <p:nvSpPr>
+          <p:cNvPr id="4" name="Text 2"/>
+          <p:cNvSpPr txBox="1"/>
+          <p:nvPr/>
+        </p:nvSpPr>
+        <p:spPr>
+          <a:xfrm>
+            <a:off x="685800" y="1325880"/>
+            <a:ext cx="2194560" cy="292608"/>
+          </a:xfrm>
+          <a:prstGeom prst="rect">
+            <a:avLst/>
+          </a:prstGeom>
+          <a:noFill/>
+          <a:ln/>
+        </p:spPr>
+        <p:txBody>
+          <a:bodyPr wrap="square" lIns="0" tIns="0" rIns="0" bIns="0" rtlCol="0" anchor="ctr"/>
+          <a:lstStyle/>
+          <a:p>
+            <a:pPr indent="0" marL="0">
+              <a:buNone/>
+            </a:pPr>
+            <a:r>
+              <a:rPr lang="en-US" sz="1300" b="1" dirty="0">
+                <a:solidFill>
+                  <a:srgbClr val="2A78D6"/>
+                </a:solidFill>
+                <a:latin typeface="Calibri" pitchFamily="34" charset="0"/>
+                <a:ea typeface="Calibri" pitchFamily="34" charset="-122"/>
+                <a:cs typeface="Calibri" pitchFamily="34" charset="-120"/>
+              </a:rPr>
+              <a:t>EXPLORE</a:t>
+            </a:r>
+            <a:endParaRPr lang="en-US" sz="1300" dirty="0"/>
+          </a:p>
+        </p:txBody>
+      </p:sp>
+      <p:sp>
+        <p:nvSpPr>
+          <p:cNvPr id="5" name="Text 3"/>
+          <p:cNvSpPr txBox="1"/>
+          <p:nvPr/>
+        </p:nvSpPr>
+        <p:spPr>
+          <a:xfrm>
+            <a:off x="685800" y="1691640"/>
+            <a:ext cx="2194560" cy="274320"/>
+          </a:xfrm>
+          <a:prstGeom prst="rect">
+            <a:avLst/>
+          </a:prstGeom>
+          <a:noFill/>
+          <a:ln/>
+        </p:spPr>
+        <p:txBody>
+          <a:bodyPr wrap="square" lIns="0" tIns="0" rIns="0" bIns="0" rtlCol="0" anchor="ctr"/>
+          <a:lstStyle/>
+          <a:p>
+            <a:pPr indent="0" marL="0">
+              <a:buNone/>
+            </a:pPr>
+            <a:r>
+              <a:rPr lang="en-US" sz="1250" dirty="0">
+                <a:solidFill>
+                  <a:srgbClr val="1C1C1E"/>
+                </a:solidFill>
+                <a:latin typeface="Calibri" pitchFamily="34" charset="0"/>
+                <a:ea typeface="Calibri" pitchFamily="34" charset="-122"/>
+                <a:cs typeface="Calibri" pitchFamily="34" charset="-120"/>
+              </a:rPr>
+              <a:t>urllib + HTTP Range</a:t>
+            </a:r>
+            <a:endParaRPr lang="en-US" sz="1250" dirty="0"/>
+          </a:p>
+        </p:txBody>
+      </p:sp>
+      <p:sp>
+        <p:nvSpPr>
+          <p:cNvPr id="6" name="Text 4"/>
+          <p:cNvSpPr txBox="1"/>
+          <p:nvPr/>
+        </p:nvSpPr>
+        <p:spPr>
+          <a:xfrm>
+            <a:off x="685800" y="2002536"/>
+            <a:ext cx="2194560" cy="274320"/>
+          </a:xfrm>
+          <a:prstGeom prst="rect">
+            <a:avLst/>
+          </a:prstGeom>
+          <a:noFill/>
+          <a:ln/>
+        </p:spPr>
+        <p:txBody>
+          <a:bodyPr wrap="square" lIns="0" tIns="0" rIns="0" bIns="0" rtlCol="0" anchor="ctr"/>
+          <a:lstStyle/>
+          <a:p>
+            <a:pPr indent="0" marL="0">
+              <a:buNone/>
+            </a:pPr>
+            <a:r>
+              <a:rPr lang="en-US" sz="1250" dirty="0">
+                <a:solidFill>
+                  <a:srgbClr val="1C1C1E"/>
+                </a:solidFill>
+                <a:latin typeface="Calibri" pitchFamily="34" charset="0"/>
+                <a:ea typeface="Calibri" pitchFamily="34" charset="-122"/>
+                <a:cs typeface="Calibri" pitchFamily="34" charset="-120"/>
+              </a:rPr>
+              <a:t>pandas</a:t>
+            </a:r>
+            <a:endParaRPr lang="en-US" sz="1250" dirty="0"/>
+          </a:p>
+        </p:txBody>
+      </p:sp>
+      <p:sp>
+        <p:nvSpPr>
+          <p:cNvPr id="7" name="Text 5"/>
+          <p:cNvSpPr txBox="1"/>
+          <p:nvPr/>
+        </p:nvSpPr>
+        <p:spPr>
+          <a:xfrm>
+            <a:off x="685800" y="2313432"/>
+            <a:ext cx="2194560" cy="274320"/>
+          </a:xfrm>
+          <a:prstGeom prst="rect">
+            <a:avLst/>
+          </a:prstGeom>
+          <a:noFill/>
+          <a:ln/>
+        </p:spPr>
+        <p:txBody>
+          <a:bodyPr wrap="square" lIns="0" tIns="0" rIns="0" bIns="0" rtlCol="0" anchor="ctr"/>
+          <a:lstStyle/>
+          <a:p>
+            <a:pPr indent="0" marL="0">
+              <a:buNone/>
+            </a:pPr>
+            <a:r>
+              <a:rPr lang="en-US" sz="1250" dirty="0">
+                <a:solidFill>
+                  <a:srgbClr val="1C1C1E"/>
+                </a:solidFill>
+                <a:latin typeface="Calibri" pitchFamily="34" charset="0"/>
+                <a:ea typeface="Calibri" pitchFamily="34" charset="-122"/>
+                <a:cs typeface="Calibri" pitchFamily="34" charset="-120"/>
+              </a:rPr>
+              <a:t>PyArrow</a:t>
+            </a:r>
+            <a:endParaRPr lang="en-US" sz="1250" dirty="0"/>
+          </a:p>
+        </p:txBody>
+      </p:sp>
+      <p:sp>
+        <p:nvSpPr>
+          <p:cNvPr id="8" name="Text 6"/>
+          <p:cNvSpPr txBox="1"/>
+          <p:nvPr/>
+        </p:nvSpPr>
+        <p:spPr>
+          <a:xfrm>
+            <a:off x="685800" y="2743200"/>
+            <a:ext cx="2194560" cy="1051560"/>
+          </a:xfrm>
+          <a:prstGeom prst="rect">
+            <a:avLst/>
+          </a:prstGeom>
+          <a:noFill/>
+          <a:ln/>
+        </p:spPr>
+        <p:txBody>
+          <a:bodyPr wrap="square" lIns="0" tIns="0" rIns="0" bIns="0" rtlCol="0" anchor="ctr"/>
+          <a:lstStyle/>
+          <a:p>
+            <a:pPr indent="0" marL="0">
+              <a:buNone/>
+            </a:pPr>
+            <a:r>
+              <a:rPr lang="en-US" sz="1150" dirty="0">
+                <a:solidFill>
+                  <a:srgbClr val="6B6A66"/>
+                </a:solidFill>
+                <a:latin typeface="Calibri" pitchFamily="34" charset="0"/>
+                <a:ea typeface="Calibri" pitchFamily="34" charset="-122"/>
+                <a:cs typeface="Calibri" pitchFamily="34" charset="-120"/>
+              </a:rPr>
+              <a:t>ler cabeçalhos sem baixar tudo; perfilar domínios e nulos</a:t>
+            </a:r>
+            <a:endParaRPr lang="en-US" sz="1150" dirty="0"/>
+          </a:p>
+        </p:txBody>
+      </p:sp>
+      <p:sp>
+        <p:nvSpPr>
+          <p:cNvPr id="9" name="Shape 7"/>
+          <p:cNvSpPr/>
+          <p:nvPr/>
+        </p:nvSpPr>
+        <p:spPr>
+          <a:xfrm>
+            <a:off x="3291840" y="1170432"/>
+            <a:ext cx="2560320" cy="2788920"/>
+          </a:xfrm>
+          <a:prstGeom prst="roundRect">
+            <a:avLst>
+              <a:gd name="adj" fmla="val 2143"/>
+            </a:avLst>
+          </a:prstGeom>
+          <a:solidFill>
+            <a:srgbClr val="F4F4F2"/>
+          </a:solidFill>
+          <a:ln w="12700">
+            <a:solidFill>
+              <a:srgbClr val="F4F4F2"/>
+            </a:solidFill>
+            <a:prstDash val="solid"/>
+          </a:ln>
+        </p:spPr>
+      </p:sp>
+      <p:sp>
+        <p:nvSpPr>
+          <p:cNvPr id="10" name="Text 8"/>
+          <p:cNvSpPr txBox="1"/>
+          <p:nvPr/>
+        </p:nvSpPr>
+        <p:spPr>
+          <a:xfrm>
+            <a:off x="3474720" y="1325880"/>
+            <a:ext cx="2194560" cy="292608"/>
+          </a:xfrm>
+          <a:prstGeom prst="rect">
+            <a:avLst/>
+          </a:prstGeom>
+          <a:noFill/>
+          <a:ln/>
+        </p:spPr>
+        <p:txBody>
+          <a:bodyPr wrap="square" lIns="0" tIns="0" rIns="0" bIns="0" rtlCol="0" anchor="ctr"/>
+          <a:lstStyle/>
+          <a:p>
+            <a:pPr indent="0" marL="0">
+              <a:buNone/>
+            </a:pPr>
+            <a:r>
+              <a:rPr lang="en-US" sz="1300" b="1" dirty="0">
+                <a:solidFill>
+                  <a:srgbClr val="EB6834"/>
+                </a:solidFill>
+                <a:latin typeface="Calibri" pitchFamily="34" charset="0"/>
+                <a:ea typeface="Calibri" pitchFamily="34" charset="-122"/>
+                <a:cs typeface="Calibri" pitchFamily="34" charset="-120"/>
+              </a:rPr>
+              <a:t>REFINE</a:t>
+            </a:r>
+            <a:endParaRPr lang="en-US" sz="1300" dirty="0"/>
+          </a:p>
+        </p:txBody>
+      </p:sp>
+      <p:sp>
+        <p:nvSpPr>
+          <p:cNvPr id="11" name="Text 9"/>
+          <p:cNvSpPr txBox="1"/>
+          <p:nvPr/>
+        </p:nvSpPr>
+        <p:spPr>
+          <a:xfrm>
+            <a:off x="3474720" y="1691640"/>
+            <a:ext cx="2194560" cy="274320"/>
+          </a:xfrm>
+          <a:prstGeom prst="rect">
+            <a:avLst/>
+          </a:prstGeom>
+          <a:noFill/>
+          <a:ln/>
+        </p:spPr>
+        <p:txBody>
+          <a:bodyPr wrap="square" lIns="0" tIns="0" rIns="0" bIns="0" rtlCol="0" anchor="ctr"/>
+          <a:lstStyle/>
+          <a:p>
+            <a:pPr indent="0" marL="0">
+              <a:buNone/>
+            </a:pPr>
+            <a:r>
+              <a:rPr lang="en-US" sz="1250" dirty="0">
+                <a:solidFill>
+                  <a:srgbClr val="1C1C1E"/>
+                </a:solidFill>
+                <a:latin typeface="Calibri" pitchFamily="34" charset="0"/>
+                <a:ea typeface="Calibri" pitchFamily="34" charset="-122"/>
+                <a:cs typeface="Calibri" pitchFamily="34" charset="-120"/>
+              </a:rPr>
+              <a:t>pandas</a:t>
+            </a:r>
+            <a:endParaRPr lang="en-US" sz="1250" dirty="0"/>
+          </a:p>
+        </p:txBody>
+      </p:sp>
+      <p:sp>
+        <p:nvSpPr>
+          <p:cNvPr id="12" name="Text 10"/>
+          <p:cNvSpPr txBox="1"/>
+          <p:nvPr/>
+        </p:nvSpPr>
+        <p:spPr>
+          <a:xfrm>
+            <a:off x="3474720" y="2002536"/>
+            <a:ext cx="2194560" cy="274320"/>
+          </a:xfrm>
+          <a:prstGeom prst="rect">
+            <a:avLst/>
+          </a:prstGeom>
+          <a:noFill/>
+          <a:ln/>
+        </p:spPr>
+        <p:txBody>
+          <a:bodyPr wrap="square" lIns="0" tIns="0" rIns="0" bIns="0" rtlCol="0" anchor="ctr"/>
+          <a:lstStyle/>
+          <a:p>
+            <a:pPr indent="0" marL="0">
+              <a:buNone/>
+            </a:pPr>
+            <a:r>
+              <a:rPr lang="en-US" sz="1250" dirty="0">
+                <a:solidFill>
+                  <a:srgbClr val="1C1C1E"/>
+                </a:solidFill>
+                <a:latin typeface="Calibri" pitchFamily="34" charset="0"/>
+                <a:ea typeface="Calibri" pitchFamily="34" charset="-122"/>
+                <a:cs typeface="Calibri" pitchFamily="34" charset="-120"/>
+              </a:rPr>
+              <a:t>pytest</a:t>
+            </a:r>
+            <a:endParaRPr lang="en-US" sz="1250" dirty="0"/>
+          </a:p>
+        </p:txBody>
+      </p:sp>
+      <p:sp>
+        <p:nvSpPr>
+          <p:cNvPr id="13" name="Text 11"/>
+          <p:cNvSpPr txBox="1"/>
+          <p:nvPr/>
+        </p:nvSpPr>
+        <p:spPr>
+          <a:xfrm>
+            <a:off x="3474720" y="2313432"/>
+            <a:ext cx="2194560" cy="274320"/>
+          </a:xfrm>
+          <a:prstGeom prst="rect">
+            <a:avLst/>
+          </a:prstGeom>
+          <a:noFill/>
+          <a:ln/>
+        </p:spPr>
+        <p:txBody>
+          <a:bodyPr wrap="square" lIns="0" tIns="0" rIns="0" bIns="0" rtlCol="0" anchor="ctr"/>
+          <a:lstStyle/>
+          <a:p>
+            <a:pPr indent="0" marL="0">
+              <a:buNone/>
+            </a:pPr>
+            <a:r>
+              <a:rPr lang="en-US" sz="1250" dirty="0">
+                <a:solidFill>
+                  <a:srgbClr val="1C1C1E"/>
+                </a:solidFill>
+                <a:latin typeface="Calibri" pitchFamily="34" charset="0"/>
+                <a:ea typeface="Calibri" pitchFamily="34" charset="-122"/>
+                <a:cs typeface="Calibri" pitchFamily="34" charset="-120"/>
+              </a:rPr>
+              <a:t>ruff</a:t>
+            </a:r>
+            <a:endParaRPr lang="en-US" sz="1250" dirty="0"/>
+          </a:p>
+        </p:txBody>
+      </p:sp>
+      <p:sp>
+        <p:nvSpPr>
+          <p:cNvPr id="14" name="Text 12"/>
+          <p:cNvSpPr txBox="1"/>
+          <p:nvPr/>
+        </p:nvSpPr>
+        <p:spPr>
+          <a:xfrm>
+            <a:off x="3474720" y="2743200"/>
+            <a:ext cx="2194560" cy="1051560"/>
+          </a:xfrm>
+          <a:prstGeom prst="rect">
+            <a:avLst/>
+          </a:prstGeom>
+          <a:noFill/>
+          <a:ln/>
+        </p:spPr>
+        <p:txBody>
+          <a:bodyPr wrap="square" lIns="0" tIns="0" rIns="0" bIns="0" rtlCol="0" anchor="ctr"/>
+          <a:lstStyle/>
+          <a:p>
+            <a:pPr indent="0" marL="0">
+              <a:buNone/>
+            </a:pPr>
+            <a:r>
+              <a:rPr lang="en-US" sz="1150" dirty="0">
+                <a:solidFill>
+                  <a:srgbClr val="6B6A66"/>
+                </a:solidFill>
+                <a:latin typeface="Calibri" pitchFamily="34" charset="0"/>
+                <a:ea typeface="Calibri" pitchFamily="34" charset="-122"/>
+                <a:cs typeface="Calibri" pitchFamily="34" charset="-120"/>
+              </a:rPr>
+              <a:t>normalizar os 4 formatos; cada decisão com teste que a fixa</a:t>
+            </a:r>
+            <a:endParaRPr lang="en-US" sz="1150" dirty="0"/>
+          </a:p>
+        </p:txBody>
+      </p:sp>
+      <p:sp>
+        <p:nvSpPr>
+          <p:cNvPr id="15" name="Shape 13"/>
+          <p:cNvSpPr/>
+          <p:nvPr/>
+        </p:nvSpPr>
+        <p:spPr>
+          <a:xfrm>
+            <a:off x="6080760" y="1170432"/>
+            <a:ext cx="2560320" cy="2788920"/>
+          </a:xfrm>
+          <a:prstGeom prst="roundRect">
+            <a:avLst>
+              <a:gd name="adj" fmla="val 2143"/>
+            </a:avLst>
+          </a:prstGeom>
+          <a:solidFill>
+            <a:srgbClr val="F4F4F2"/>
+          </a:solidFill>
+          <a:ln w="12700">
+            <a:solidFill>
+              <a:srgbClr val="F4F4F2"/>
+            </a:solidFill>
+            <a:prstDash val="solid"/>
+          </a:ln>
+        </p:spPr>
+      </p:sp>
+      <p:sp>
+        <p:nvSpPr>
+          <p:cNvPr id="16" name="Text 14"/>
+          <p:cNvSpPr txBox="1"/>
+          <p:nvPr/>
+        </p:nvSpPr>
+        <p:spPr>
+          <a:xfrm>
+            <a:off x="6263640" y="1325880"/>
+            <a:ext cx="2194560" cy="292608"/>
+          </a:xfrm>
+          <a:prstGeom prst="rect">
+            <a:avLst/>
+          </a:prstGeom>
+          <a:noFill/>
+          <a:ln/>
+        </p:spPr>
+        <p:txBody>
+          <a:bodyPr wrap="square" lIns="0" tIns="0" rIns="0" bIns="0" rtlCol="0" anchor="ctr"/>
+          <a:lstStyle/>
+          <a:p>
+            <a:pPr indent="0" marL="0">
+              <a:buNone/>
+            </a:pPr>
+            <a:r>
+              <a:rPr lang="en-US" sz="1300" b="1" dirty="0">
+                <a:solidFill>
+                  <a:srgbClr val="1BAF7A"/>
+                </a:solidFill>
+                <a:latin typeface="Calibri" pitchFamily="34" charset="0"/>
+                <a:ea typeface="Calibri" pitchFamily="34" charset="-122"/>
+                <a:cs typeface="Calibri" pitchFamily="34" charset="-120"/>
+              </a:rPr>
+              <a:t>PRODUCE</a:t>
+            </a:r>
+            <a:endParaRPr lang="en-US" sz="1300" dirty="0"/>
+          </a:p>
+        </p:txBody>
+      </p:sp>
+      <p:sp>
+        <p:nvSpPr>
+          <p:cNvPr id="17" name="Text 15"/>
+          <p:cNvSpPr txBox="1"/>
+          <p:nvPr/>
+        </p:nvSpPr>
+        <p:spPr>
+          <a:xfrm>
+            <a:off x="6263640" y="1691640"/>
+            <a:ext cx="2194560" cy="274320"/>
+          </a:xfrm>
+          <a:prstGeom prst="rect">
+            <a:avLst/>
+          </a:prstGeom>
+          <a:noFill/>
+          <a:ln/>
+        </p:spPr>
+        <p:txBody>
+          <a:bodyPr wrap="square" lIns="0" tIns="0" rIns="0" bIns="0" rtlCol="0" anchor="ctr"/>
+          <a:lstStyle/>
+          <a:p>
+            <a:pPr indent="0" marL="0">
+              <a:buNone/>
+            </a:pPr>
+            <a:r>
+              <a:rPr lang="en-US" sz="1250" dirty="0">
+                <a:solidFill>
+                  <a:srgbClr val="1C1C1E"/>
+                </a:solidFill>
+                <a:latin typeface="Calibri" pitchFamily="34" charset="0"/>
+                <a:ea typeface="Calibri" pitchFamily="34" charset="-122"/>
+                <a:cs typeface="Calibri" pitchFamily="34" charset="-120"/>
+              </a:rPr>
+              <a:t>Parquet + zstd</a:t>
+            </a:r>
+            <a:endParaRPr lang="en-US" sz="1250" dirty="0"/>
+          </a:p>
+        </p:txBody>
+      </p:sp>
+      <p:sp>
+        <p:nvSpPr>
+          <p:cNvPr id="18" name="Text 16"/>
+          <p:cNvSpPr txBox="1"/>
+          <p:nvPr/>
+        </p:nvSpPr>
+        <p:spPr>
+          <a:xfrm>
+            <a:off x="6263640" y="2002536"/>
+            <a:ext cx="2194560" cy="274320"/>
+          </a:xfrm>
+          <a:prstGeom prst="rect">
+            <a:avLst/>
+          </a:prstGeom>
+          <a:noFill/>
+          <a:ln/>
+        </p:spPr>
+        <p:txBody>
+          <a:bodyPr wrap="square" lIns="0" tIns="0" rIns="0" bIns="0" rtlCol="0" anchor="ctr"/>
+          <a:lstStyle/>
+          <a:p>
+            <a:pPr indent="0" marL="0">
+              <a:buNone/>
+            </a:pPr>
+            <a:r>
+              <a:rPr lang="en-US" sz="1250" dirty="0">
+                <a:solidFill>
+                  <a:srgbClr val="1C1C1E"/>
+                </a:solidFill>
+                <a:latin typeface="Calibri" pitchFamily="34" charset="0"/>
+                <a:ea typeface="Calibri" pitchFamily="34" charset="-122"/>
+                <a:cs typeface="Calibri" pitchFamily="34" charset="-120"/>
+              </a:rPr>
+              <a:t>matplotlib</a:t>
+            </a:r>
+            <a:endParaRPr lang="en-US" sz="1250" dirty="0"/>
+          </a:p>
+        </p:txBody>
+      </p:sp>
+      <p:sp>
+        <p:nvSpPr>
+          <p:cNvPr id="19" name="Text 17"/>
+          <p:cNvSpPr txBox="1"/>
+          <p:nvPr/>
+        </p:nvSpPr>
+        <p:spPr>
+          <a:xfrm>
+            <a:off x="6263640" y="2313432"/>
+            <a:ext cx="2194560" cy="274320"/>
+          </a:xfrm>
+          <a:prstGeom prst="rect">
+            <a:avLst/>
+          </a:prstGeom>
+          <a:noFill/>
+          <a:ln/>
+        </p:spPr>
+        <p:txBody>
+          <a:bodyPr wrap="square" lIns="0" tIns="0" rIns="0" bIns="0" rtlCol="0" anchor="ctr"/>
+          <a:lstStyle/>
+          <a:p>
+            <a:pPr indent="0" marL="0">
+              <a:buNone/>
+            </a:pPr>
+            <a:r>
+              <a:rPr lang="en-US" sz="1250" dirty="0">
+                <a:solidFill>
+                  <a:srgbClr val="1C1C1E"/>
+                </a:solidFill>
+                <a:latin typeface="Calibri" pitchFamily="34" charset="0"/>
+                <a:ea typeface="Calibri" pitchFamily="34" charset="-122"/>
+                <a:cs typeface="Calibri" pitchFamily="34" charset="-120"/>
+              </a:rPr>
+              <a:t>Colab · Git</a:t>
+            </a:r>
+            <a:endParaRPr lang="en-US" sz="1250" dirty="0"/>
+          </a:p>
+        </p:txBody>
+      </p:sp>
+      <p:sp>
+        <p:nvSpPr>
+          <p:cNvPr id="20" name="Text 18"/>
+          <p:cNvSpPr txBox="1"/>
+          <p:nvPr/>
+        </p:nvSpPr>
+        <p:spPr>
+          <a:xfrm>
+            <a:off x="6263640" y="2743200"/>
+            <a:ext cx="2194560" cy="1051560"/>
+          </a:xfrm>
+          <a:prstGeom prst="rect">
+            <a:avLst/>
+          </a:prstGeom>
+          <a:noFill/>
+          <a:ln/>
+        </p:spPr>
+        <p:txBody>
+          <a:bodyPr wrap="square" lIns="0" tIns="0" rIns="0" bIns="0" rtlCol="0" anchor="ctr"/>
+          <a:lstStyle/>
+          <a:p>
+            <a:pPr indent="0" marL="0">
+              <a:buNone/>
+            </a:pPr>
+            <a:r>
+              <a:rPr lang="en-US" sz="1150" dirty="0">
+                <a:solidFill>
+                  <a:srgbClr val="6B6A66"/>
+                </a:solidFill>
+                <a:latin typeface="Calibri" pitchFamily="34" charset="0"/>
+                <a:ea typeface="Calibri" pitchFamily="34" charset="-122"/>
+                <a:cs typeface="Calibri" pitchFamily="34" charset="-120"/>
+              </a:rPr>
+              <a:t>base consolidada, figuras e notebook reproduzível</a:t>
+            </a:r>
+            <a:endParaRPr lang="en-US" sz="1150" dirty="0"/>
+          </a:p>
+        </p:txBody>
+      </p:sp>
+      <p:sp>
+        <p:nvSpPr>
+          <p:cNvPr id="21" name="Text 19"/>
           <p:cNvSpPr txBox="1"/>
           <p:nvPr/>
         </p:nvSpPr>
         <p:spPr>
           <a:xfrm>
             <a:off x="502920" y="4160520"/>
-            <a:ext cx="8138160" cy="777240"/>
-          </a:xfrm>
-          <a:prstGeom prst="rect">
-            <a:avLst/>
-          </a:prstGeom>
-          <a:noFill/>
-          <a:ln/>
-        </p:spPr>
-        <p:txBody>
-          <a:bodyPr wrap="square" lIns="0" tIns="0" rIns="0" bIns="0" rtlCol="0" anchor="ctr"/>
-          <a:lstStyle/>
-          <a:p>
-            <a:pPr indent="0" marL="0">
-              <a:buNone/>
-            </a:pPr>
-            <a:r>
-              <a:rPr lang="en-US" sz="1350" dirty="0">
+            <a:ext cx="8138160" cy="502920"/>
+          </a:xfrm>
+          <a:prstGeom prst="rect">
+            <a:avLst/>
+          </a:prstGeom>
+          <a:noFill/>
+          <a:ln/>
+        </p:spPr>
+        <p:txBody>
+          <a:bodyPr wrap="square" lIns="0" tIns="0" rIns="0" bIns="0" rtlCol="0" anchor="ctr"/>
+          <a:lstStyle/>
+          <a:p>
+            <a:pPr indent="0" marL="0">
+              <a:buNone/>
+            </a:pPr>
+            <a:r>
+              <a:rPr lang="en-US" sz="1300" dirty="0">
                 <a:solidFill>
                   <a:srgbClr val="1C1C1E"/>
                 </a:solidFill>
@@ -5963,9 +7149,9 @@
                 <a:ea typeface="Calibri" pitchFamily="34" charset="-122"/>
                 <a:cs typeface="Calibri" pitchFamily="34" charset="-120"/>
               </a:rPr>
-              <a:t>O acidente de trajeto é 2,7× mais letal que o típico, apesar de 3,3× menos frequente. E o transporte rodoviário lidera entre os setores, com 4× a média. Duas análises independentes apontando para o mesmo mecanismo: o trânsito.</a:t>
-            </a:r>
-            <a:endParaRPr lang="en-US" sz="1350" dirty="0"/>
+              <a:t>Python em todas as etapas. O que mudou foi o papel: explorar com requisições leves, refinar com testes, produzir com formato colunar.</a:t>
+            </a:r>
+            <a:endParaRPr lang="en-US" sz="1300" dirty="0"/>
           </a:p>
         </p:txBody>
       </p:sp>

</xml_diff>